<commit_message>
Resolve portfolio audit findings and verify artifacts
</commit_message>
<xml_diff>
--- a/presentations/mobile-robot-presentation-fr.pptx
+++ b/presentations/mobile-robot-presentation-fr.pptx
@@ -1,6 +1,6 @@
 
 <file path=ppt/presentation.xml><?xml version="1.0" encoding="utf-8"?>
-<p:presentation xmlns:a="http://schemas.openxmlformats.org/drawingml/2006/main" xmlns:r="http://schemas.openxmlformats.org/officeDocument/2006/relationships" xmlns:p="http://schemas.openxmlformats.org/presentationml/2006/main" strictFirstAndLastChars="0" saveSubsetFonts="1" autoCompressPictures="0">
+<p:presentation xmlns:a="http://schemas.openxmlformats.org/drawingml/2006/main" xmlns:r="http://schemas.openxmlformats.org/officeDocument/2006/relationships" xmlns:p="http://schemas.openxmlformats.org/presentationml/2006/main" removePersonalInfoOnSave="1" strictFirstAndLastChars="0" saveSubsetFonts="1" autoCompressPictures="0">
   <p:sldMasterIdLst>
     <p:sldMasterId id="2147483679" r:id="rId1"/>
   </p:sldMasterIdLst>
@@ -275,13 +275,7 @@
 
 <file path=ppt/commentAuthors.xml><?xml version="1.0" encoding="utf-8"?>
 <p:cmAuthorLst xmlns:a="http://schemas.openxmlformats.org/drawingml/2006/main" xmlns:r="http://schemas.openxmlformats.org/officeDocument/2006/relationships" xmlns:p="http://schemas.openxmlformats.org/presentationml/2006/main">
-  <p:cmAuthor id="1" name="EL AKKAOUI ADAM" initials="EAA" lastIdx="1" clrIdx="0">
-    <p:extLst>
-      <p:ext uri="{19B8F6BF-5375-455C-9EA6-DF929625EA0E}">
-        <p15:presenceInfo xmlns:p15="http://schemas.microsoft.com/office/powerpoint/2012/main" userId="EL AKKAOUI ADAM" providerId="None"/>
-      </p:ext>
-    </p:extLst>
-  </p:cmAuthor>
+  <p:cmAuthor id="2" name="Auteur" initials="A" lastIdx="0" clrIdx="1"/>
 </p:cmAuthorLst>
 </file>
 
@@ -18715,7 +18709,7 @@
                 <a:solidFill>
                   <a:schemeClr val="accent6"/>
                 </a:solidFill>
-                <a:latin typeface="Georgia" panose="0204[phone redacted]020303" pitchFamily="18" charset="0"/>
+                <a:latin typeface="Georgia" panose="02040502050405020303" pitchFamily="18" charset="0"/>
               </a:rPr>
               <a:t>C</a:t>
             </a:r>
@@ -18725,7 +18719,7 @@
                   <a:schemeClr val="accent6"/>
                 </a:solidFill>
                 <a:effectLst/>
-                <a:latin typeface="Georgia" panose="0204[phone redacted]020303" pitchFamily="18" charset="0"/>
+                <a:latin typeface="Georgia" panose="02040502050405020303" pitchFamily="18" charset="0"/>
               </a:rPr>
               <a:t>ircuit du robot mobile</a:t>
             </a:r>
@@ -18815,7 +18809,7 @@
                 <a:effectLst/>
                 <a:uLnTx/>
                 <a:uFillTx/>
-                <a:latin typeface="Arial" panose="020B[phone redacted]020204" pitchFamily="34" charset="0"/>
+                <a:latin typeface="Arial" panose="020B0604020202020204" pitchFamily="34" charset="0"/>
                 <a:cs typeface="Assistant"/>
                 <a:sym typeface="Assistant"/>
               </a:rPr>
@@ -18832,7 +18826,7 @@
                 <a:effectLst/>
                 <a:uLnTx/>
                 <a:uFillTx/>
-                <a:latin typeface="Arial" panose="020B[phone redacted]020204" pitchFamily="34" charset="0"/>
+                <a:latin typeface="Arial" panose="020B0604020202020204" pitchFamily="34" charset="0"/>
                 <a:cs typeface="Assistant"/>
                 <a:sym typeface="Assistant"/>
               </a:rPr>
@@ -18849,7 +18843,7 @@
                 <a:effectLst/>
                 <a:uLnTx/>
                 <a:uFillTx/>
-                <a:latin typeface="Arial" panose="020B[phone redacted]020204" pitchFamily="34" charset="0"/>
+                <a:latin typeface="Arial" panose="020B0604020202020204" pitchFamily="34" charset="0"/>
                 <a:cs typeface="Assistant"/>
                 <a:sym typeface="Assistant"/>
               </a:rPr>
@@ -18886,7 +18880,7 @@
               <a:effectLst/>
               <a:uLnTx/>
               <a:uFillTx/>
-              <a:latin typeface="Arial" panose="020B[phone redacted]020204" pitchFamily="34" charset="0"/>
+              <a:latin typeface="Arial" panose="020B0604020202020204" pitchFamily="34" charset="0"/>
               <a:cs typeface="Assistant"/>
               <a:sym typeface="Assistant"/>
             </a:endParaRPr>
@@ -18922,7 +18916,7 @@
                 <a:effectLst/>
                 <a:uLnTx/>
                 <a:uFillTx/>
-                <a:latin typeface="Arial" panose="020B[phone redacted]020204" pitchFamily="34" charset="0"/>
+                <a:latin typeface="Arial" panose="020B0604020202020204" pitchFamily="34" charset="0"/>
                 <a:cs typeface="Assistant"/>
                 <a:sym typeface="Assistant"/>
               </a:rPr>
@@ -18939,7 +18933,7 @@
                 <a:effectLst/>
                 <a:uLnTx/>
                 <a:uFillTx/>
-                <a:latin typeface="Arial" panose="020B[phone redacted]020204" pitchFamily="34" charset="0"/>
+                <a:latin typeface="Arial" panose="020B0604020202020204" pitchFamily="34" charset="0"/>
                 <a:cs typeface="Assistant"/>
                 <a:sym typeface="Assistant"/>
               </a:rPr>
@@ -18950,7 +18944,7 @@
                 <a:solidFill>
                   <a:srgbClr val="FFFFFF"/>
                 </a:solidFill>
-                <a:latin typeface="Arial" panose="020B[phone redacted]020204" pitchFamily="34" charset="0"/>
+                <a:latin typeface="Arial" panose="020B0604020202020204" pitchFamily="34" charset="0"/>
                 <a:cs typeface="Assistant"/>
                 <a:sym typeface="Assistant"/>
               </a:rPr>
@@ -18967,7 +18961,7 @@
                 <a:effectLst/>
                 <a:uLnTx/>
                 <a:uFillTx/>
-                <a:latin typeface="Arial" panose="020B[phone redacted]020204" pitchFamily="34" charset="0"/>
+                <a:latin typeface="Arial" panose="020B0604020202020204" pitchFamily="34" charset="0"/>
                 <a:cs typeface="Assistant"/>
                 <a:sym typeface="Assistant"/>
               </a:rPr>
@@ -19005,7 +18999,7 @@
                 <a:effectLst/>
                 <a:uLnTx/>
                 <a:uFillTx/>
-                <a:latin typeface="Arial" panose="020B[phone redacted]020204" pitchFamily="34" charset="0"/>
+                <a:latin typeface="Arial" panose="020B0604020202020204" pitchFamily="34" charset="0"/>
                 <a:cs typeface="Assistant"/>
                 <a:sym typeface="Assistant"/>
               </a:rPr>
@@ -19022,7 +19016,7 @@
                 <a:effectLst/>
                 <a:uLnTx/>
                 <a:uFillTx/>
-                <a:latin typeface="Arial" panose="020B[phone redacted]020204" pitchFamily="34" charset="0"/>
+                <a:latin typeface="Arial" panose="020B0604020202020204" pitchFamily="34" charset="0"/>
                 <a:cs typeface="Assistant"/>
                 <a:sym typeface="Assistant"/>
               </a:rPr>
@@ -19033,7 +19027,7 @@
                 <a:solidFill>
                   <a:srgbClr val="FFFFFF"/>
                 </a:solidFill>
-                <a:latin typeface="Arial" panose="020B[phone redacted]020204" pitchFamily="34" charset="0"/>
+                <a:latin typeface="Arial" panose="020B0604020202020204" pitchFamily="34" charset="0"/>
                 <a:cs typeface="Assistant"/>
                 <a:sym typeface="Assistant"/>
               </a:rPr>
@@ -19050,7 +19044,7 @@
                 <a:effectLst/>
                 <a:uLnTx/>
                 <a:uFillTx/>
-                <a:latin typeface="Arial" panose="020B[phone redacted]020204" pitchFamily="34" charset="0"/>
+                <a:latin typeface="Arial" panose="020B0604020202020204" pitchFamily="34" charset="0"/>
                 <a:cs typeface="Assistant"/>
                 <a:sym typeface="Assistant"/>
               </a:rPr>
@@ -19088,7 +19082,7 @@
                 <a:effectLst/>
                 <a:uLnTx/>
                 <a:uFillTx/>
-                <a:latin typeface="Arial" panose="020B[phone redacted]020204" pitchFamily="34" charset="0"/>
+                <a:latin typeface="Arial" panose="020B0604020202020204" pitchFamily="34" charset="0"/>
                 <a:cs typeface="Assistant"/>
                 <a:sym typeface="Assistant"/>
               </a:rPr>
@@ -19105,7 +19099,7 @@
                 <a:effectLst/>
                 <a:uLnTx/>
                 <a:uFillTx/>
-                <a:latin typeface="Arial" panose="020B[phone redacted]020204" pitchFamily="34" charset="0"/>
+                <a:latin typeface="Arial" panose="020B0604020202020204" pitchFamily="34" charset="0"/>
                 <a:cs typeface="Assistant"/>
                 <a:sym typeface="Assistant"/>
               </a:rPr>
@@ -19122,7 +19116,7 @@
                 <a:effectLst/>
                 <a:uLnTx/>
                 <a:uFillTx/>
-                <a:latin typeface="Arial" panose="020B[phone redacted]020204" pitchFamily="34" charset="0"/>
+                <a:latin typeface="Arial" panose="020B0604020202020204" pitchFamily="34" charset="0"/>
                 <a:cs typeface="Assistant"/>
                 <a:sym typeface="Assistant"/>
               </a:rPr>
@@ -19160,7 +19154,7 @@
                 <a:effectLst/>
                 <a:uLnTx/>
                 <a:uFillTx/>
-                <a:latin typeface="Arial" panose="020B[phone redacted]020204" pitchFamily="34" charset="0"/>
+                <a:latin typeface="Arial" panose="020B0604020202020204" pitchFamily="34" charset="0"/>
                 <a:cs typeface="Assistant"/>
                 <a:sym typeface="Assistant"/>
               </a:rPr>
@@ -19177,7 +19171,7 @@
                 <a:effectLst/>
                 <a:uLnTx/>
                 <a:uFillTx/>
-                <a:latin typeface="Arial" panose="020B[phone redacted]020204" pitchFamily="34" charset="0"/>
+                <a:latin typeface="Arial" panose="020B0604020202020204" pitchFamily="34" charset="0"/>
                 <a:cs typeface="Assistant"/>
                 <a:sym typeface="Assistant"/>
               </a:rPr>
@@ -19194,7 +19188,7 @@
                 <a:effectLst/>
                 <a:uLnTx/>
                 <a:uFillTx/>
-                <a:latin typeface="Arial" panose="020B[phone redacted]020204" pitchFamily="34" charset="0"/>
+                <a:latin typeface="Arial" panose="020B0604020202020204" pitchFamily="34" charset="0"/>
                 <a:cs typeface="Assistant"/>
                 <a:sym typeface="Assistant"/>
               </a:rPr>
@@ -19205,7 +19199,7 @@
                 <a:solidFill>
                   <a:schemeClr val="accent4"/>
                 </a:solidFill>
-                <a:latin typeface="Arial" panose="020B[phone redacted]020204" pitchFamily="34" charset="0"/>
+                <a:latin typeface="Arial" panose="020B0604020202020204" pitchFamily="34" charset="0"/>
                 <a:cs typeface="Assistant"/>
                 <a:sym typeface="Assistant"/>
               </a:rPr>
@@ -19222,7 +19216,7 @@
                 <a:effectLst/>
                 <a:uLnTx/>
                 <a:uFillTx/>
-                <a:latin typeface="Arial" panose="020B[phone redacted]020204" pitchFamily="34" charset="0"/>
+                <a:latin typeface="Arial" panose="020B0604020202020204" pitchFamily="34" charset="0"/>
                 <a:cs typeface="Assistant"/>
                 <a:sym typeface="Assistant"/>
               </a:rPr>
@@ -19260,7 +19254,7 @@
                 <a:effectLst/>
                 <a:uLnTx/>
                 <a:uFillTx/>
-                <a:latin typeface="Arial" panose="020B[phone redacted]020204" pitchFamily="34" charset="0"/>
+                <a:latin typeface="Arial" panose="020B0604020202020204" pitchFamily="34" charset="0"/>
                 <a:cs typeface="Assistant"/>
                 <a:sym typeface="Assistant"/>
               </a:rPr>
@@ -19277,7 +19271,7 @@
                 <a:effectLst/>
                 <a:uLnTx/>
                 <a:uFillTx/>
-                <a:latin typeface="Arial" panose="020B[phone redacted]020204" pitchFamily="34" charset="0"/>
+                <a:latin typeface="Arial" panose="020B0604020202020204" pitchFamily="34" charset="0"/>
                 <a:cs typeface="Assistant"/>
                 <a:sym typeface="Assistant"/>
               </a:rPr>
@@ -19294,7 +19288,7 @@
                 <a:effectLst/>
                 <a:uLnTx/>
                 <a:uFillTx/>
-                <a:latin typeface="Arial" panose="020B[phone redacted]020204" pitchFamily="34" charset="0"/>
+                <a:latin typeface="Arial" panose="020B0604020202020204" pitchFamily="34" charset="0"/>
                 <a:cs typeface="Assistant"/>
                 <a:sym typeface="Assistant"/>
               </a:rPr>
@@ -19332,7 +19326,7 @@
                 <a:effectLst/>
                 <a:uLnTx/>
                 <a:uFillTx/>
-                <a:latin typeface="Arial" panose="020B[phone redacted]020204" pitchFamily="34" charset="0"/>
+                <a:latin typeface="Arial" panose="020B0604020202020204" pitchFamily="34" charset="0"/>
                 <a:cs typeface="Assistant"/>
                 <a:sym typeface="Assistant"/>
               </a:rPr>
@@ -19349,7 +19343,7 @@
                 <a:effectLst/>
                 <a:uLnTx/>
                 <a:uFillTx/>
-                <a:latin typeface="Arial" panose="020B[phone redacted]020204" pitchFamily="34" charset="0"/>
+                <a:latin typeface="Arial" panose="020B0604020202020204" pitchFamily="34" charset="0"/>
                 <a:cs typeface="Assistant"/>
                 <a:sym typeface="Assistant"/>
               </a:rPr>
@@ -19360,7 +19354,7 @@
                 <a:solidFill>
                   <a:srgbClr val="FFFFFF"/>
                 </a:solidFill>
-                <a:latin typeface="Arial" panose="020B[phone redacted]020204" pitchFamily="34" charset="0"/>
+                <a:latin typeface="Arial" panose="020B0604020202020204" pitchFamily="34" charset="0"/>
                 <a:cs typeface="Assistant"/>
                 <a:sym typeface="Assistant"/>
               </a:rPr>
@@ -19377,7 +19371,7 @@
                 <a:effectLst/>
                 <a:uLnTx/>
                 <a:uFillTx/>
-                <a:latin typeface="Arial" panose="020B[phone redacted]020204" pitchFamily="34" charset="0"/>
+                <a:latin typeface="Arial" panose="020B0604020202020204" pitchFamily="34" charset="0"/>
                 <a:cs typeface="Assistant"/>
                 <a:sym typeface="Assistant"/>
               </a:rPr>
@@ -19415,7 +19409,7 @@
                 <a:effectLst/>
                 <a:uLnTx/>
                 <a:uFillTx/>
-                <a:latin typeface="Arial" panose="020B[phone redacted]020204" pitchFamily="34" charset="0"/>
+                <a:latin typeface="Arial" panose="020B0604020202020204" pitchFamily="34" charset="0"/>
                 <a:cs typeface="Assistant"/>
                 <a:sym typeface="Assistant"/>
               </a:rPr>
@@ -19432,7 +19426,7 @@
                 <a:effectLst/>
                 <a:uLnTx/>
                 <a:uFillTx/>
-                <a:latin typeface="Arial" panose="020B[phone redacted]020204" pitchFamily="34" charset="0"/>
+                <a:latin typeface="Arial" panose="020B0604020202020204" pitchFamily="34" charset="0"/>
                 <a:cs typeface="Assistant"/>
                 <a:sym typeface="Assistant"/>
               </a:rPr>
@@ -19449,7 +19443,7 @@
                 <a:effectLst/>
                 <a:uLnTx/>
                 <a:uFillTx/>
-                <a:latin typeface="Arial" panose="020B[phone redacted]020204" pitchFamily="34" charset="0"/>
+                <a:latin typeface="Arial" panose="020B0604020202020204" pitchFamily="34" charset="0"/>
                 <a:cs typeface="Assistant"/>
                 <a:sym typeface="Assistant"/>
               </a:rPr>
@@ -19466,7 +19460,7 @@
                 <a:effectLst/>
                 <a:uLnTx/>
                 <a:uFillTx/>
-                <a:latin typeface="Arial" panose="020B[phone redacted]020204" pitchFamily="34" charset="0"/>
+                <a:latin typeface="Arial" panose="020B0604020202020204" pitchFamily="34" charset="0"/>
                 <a:cs typeface="Assistant"/>
                 <a:sym typeface="Assistant"/>
               </a:rPr>
@@ -19483,7 +19477,7 @@
                 <a:effectLst/>
                 <a:uLnTx/>
                 <a:uFillTx/>
-                <a:latin typeface="Arial" panose="020B[phone redacted]020204" pitchFamily="34" charset="0"/>
+                <a:latin typeface="Arial" panose="020B0604020202020204" pitchFamily="34" charset="0"/>
                 <a:cs typeface="Assistant"/>
                 <a:sym typeface="Assistant"/>
               </a:rPr>
@@ -19521,7 +19515,7 @@
                 <a:effectLst/>
                 <a:uLnTx/>
                 <a:uFillTx/>
-                <a:latin typeface="Arial" panose="020B[phone redacted]020204" pitchFamily="34" charset="0"/>
+                <a:latin typeface="Arial" panose="020B0604020202020204" pitchFamily="34" charset="0"/>
                 <a:cs typeface="Assistant"/>
                 <a:sym typeface="Assistant"/>
               </a:rPr>
@@ -19532,7 +19526,7 @@
                 <a:solidFill>
                   <a:srgbClr val="FFFFFF"/>
                 </a:solidFill>
-                <a:latin typeface="Arial" panose="020B[phone redacted]020204" pitchFamily="34" charset="0"/>
+                <a:latin typeface="Arial" panose="020B0604020202020204" pitchFamily="34" charset="0"/>
                 <a:cs typeface="Assistant"/>
                 <a:sym typeface="Assistant"/>
               </a:rPr>
@@ -19549,7 +19543,7 @@
                 <a:effectLst/>
                 <a:uLnTx/>
                 <a:uFillTx/>
-                <a:latin typeface="Arial" panose="020B[phone redacted]020204" pitchFamily="34" charset="0"/>
+                <a:latin typeface="Arial" panose="020B0604020202020204" pitchFamily="34" charset="0"/>
                 <a:cs typeface="Assistant"/>
                 <a:sym typeface="Assistant"/>
               </a:rPr>
@@ -19586,7 +19580,7 @@
               <a:effectLst/>
               <a:uLnTx/>
               <a:uFillTx/>
-              <a:latin typeface="Arial" panose="020B[phone redacted]020204" pitchFamily="34" charset="0"/>
+              <a:latin typeface="Arial" panose="020B0604020202020204" pitchFamily="34" charset="0"/>
               <a:cs typeface="Assistant"/>
               <a:sym typeface="Assistant"/>
             </a:endParaRPr>
@@ -19622,7 +19616,7 @@
                 <a:effectLst/>
                 <a:uLnTx/>
                 <a:uFillTx/>
-                <a:latin typeface="Arial" panose="020B[phone redacted]020204" pitchFamily="34" charset="0"/>
+                <a:latin typeface="Arial" panose="020B0604020202020204" pitchFamily="34" charset="0"/>
                 <a:cs typeface="Assistant"/>
                 <a:sym typeface="Assistant"/>
               </a:rPr>
@@ -19639,7 +19633,7 @@
                 <a:effectLst/>
                 <a:uLnTx/>
                 <a:uFillTx/>
-                <a:latin typeface="Arial" panose="020B[phone redacted]020204" pitchFamily="34" charset="0"/>
+                <a:latin typeface="Arial" panose="020B0604020202020204" pitchFamily="34" charset="0"/>
                 <a:cs typeface="Assistant"/>
                 <a:sym typeface="Assistant"/>
               </a:rPr>
@@ -19677,7 +19671,7 @@
                 <a:effectLst/>
                 <a:uLnTx/>
                 <a:uFillTx/>
-                <a:latin typeface="Arial" panose="020B[phone redacted]020204" pitchFamily="34" charset="0"/>
+                <a:latin typeface="Arial" panose="020B0604020202020204" pitchFamily="34" charset="0"/>
                 <a:cs typeface="Assistant"/>
                 <a:sym typeface="Assistant"/>
               </a:rPr>
@@ -19709,7 +19703,7 @@
                 <a:solidFill>
                   <a:srgbClr val="FFFFFF"/>
                 </a:solidFill>
-                <a:latin typeface="Arial" panose="020B[phone redacted]020204" pitchFamily="34" charset="0"/>
+                <a:latin typeface="Arial" panose="020B0604020202020204" pitchFamily="34" charset="0"/>
                 <a:cs typeface="Assistant"/>
                 <a:sym typeface="Assistant"/>
               </a:rPr>
@@ -19726,7 +19720,7 @@
                 <a:effectLst/>
                 <a:uLnTx/>
                 <a:uFillTx/>
-                <a:latin typeface="Arial" panose="020B[phone redacted]020204" pitchFamily="34" charset="0"/>
+                <a:latin typeface="Arial" panose="020B0604020202020204" pitchFamily="34" charset="0"/>
                 <a:cs typeface="Assistant"/>
                 <a:sym typeface="Assistant"/>
               </a:rPr>
@@ -19743,7 +19737,7 @@
                 <a:effectLst/>
                 <a:uLnTx/>
                 <a:uFillTx/>
-                <a:latin typeface="Arial" panose="020B[phone redacted]020204" pitchFamily="34" charset="0"/>
+                <a:latin typeface="Arial" panose="020B0604020202020204" pitchFamily="34" charset="0"/>
                 <a:cs typeface="Assistant"/>
                 <a:sym typeface="Assistant"/>
               </a:rPr>
@@ -19760,7 +19754,7 @@
                 <a:effectLst/>
                 <a:uLnTx/>
                 <a:uFillTx/>
-                <a:latin typeface="Arial" panose="020B[phone redacted]020204" pitchFamily="34" charset="0"/>
+                <a:latin typeface="Arial" panose="020B0604020202020204" pitchFamily="34" charset="0"/>
                 <a:cs typeface="Assistant"/>
                 <a:sym typeface="Assistant"/>
               </a:rPr>
@@ -19798,7 +19792,7 @@
                 <a:effectLst/>
                 <a:uLnTx/>
                 <a:uFillTx/>
-                <a:latin typeface="Arial" panose="020B[phone redacted]020204" pitchFamily="34" charset="0"/>
+                <a:latin typeface="Arial" panose="020B0604020202020204" pitchFamily="34" charset="0"/>
                 <a:cs typeface="Assistant"/>
                 <a:sym typeface="Assistant"/>
               </a:rPr>
@@ -19815,7 +19809,7 @@
                 <a:effectLst/>
                 <a:uLnTx/>
                 <a:uFillTx/>
-                <a:latin typeface="Arial" panose="020B[phone redacted]020204" pitchFamily="34" charset="0"/>
+                <a:latin typeface="Arial" panose="020B0604020202020204" pitchFamily="34" charset="0"/>
                 <a:cs typeface="Assistant"/>
                 <a:sym typeface="Assistant"/>
               </a:rPr>
@@ -19832,7 +19826,7 @@
                 <a:effectLst/>
                 <a:uLnTx/>
                 <a:uFillTx/>
-                <a:latin typeface="Arial" panose="020B[phone redacted]020204" pitchFamily="34" charset="0"/>
+                <a:latin typeface="Arial" panose="020B0604020202020204" pitchFamily="34" charset="0"/>
                 <a:cs typeface="Assistant"/>
                 <a:sym typeface="Assistant"/>
               </a:rPr>
@@ -19870,7 +19864,7 @@
                 <a:effectLst/>
                 <a:uLnTx/>
                 <a:uFillTx/>
-                <a:latin typeface="Arial" panose="020B[phone redacted]020204" pitchFamily="34" charset="0"/>
+                <a:latin typeface="Arial" panose="020B0604020202020204" pitchFamily="34" charset="0"/>
                 <a:cs typeface="Assistant"/>
                 <a:sym typeface="Assistant"/>
               </a:rPr>
@@ -19887,7 +19881,7 @@
                 <a:effectLst/>
                 <a:uLnTx/>
                 <a:uFillTx/>
-                <a:latin typeface="Arial" panose="020B[phone redacted]020204" pitchFamily="34" charset="0"/>
+                <a:latin typeface="Arial" panose="020B0604020202020204" pitchFamily="34" charset="0"/>
                 <a:cs typeface="Assistant"/>
                 <a:sym typeface="Assistant"/>
               </a:rPr>
@@ -19904,7 +19898,7 @@
                 <a:effectLst/>
                 <a:uLnTx/>
                 <a:uFillTx/>
-                <a:latin typeface="Arial" panose="020B[phone redacted]020204" pitchFamily="34" charset="0"/>
+                <a:latin typeface="Arial" panose="020B0604020202020204" pitchFamily="34" charset="0"/>
                 <a:cs typeface="Assistant"/>
                 <a:sym typeface="Assistant"/>
               </a:rPr>
@@ -19942,7 +19936,7 @@
                 <a:effectLst/>
                 <a:uLnTx/>
                 <a:uFillTx/>
-                <a:latin typeface="Arial" panose="020B[phone redacted]020204" pitchFamily="34" charset="0"/>
+                <a:latin typeface="Arial" panose="020B0604020202020204" pitchFamily="34" charset="0"/>
                 <a:cs typeface="Assistant"/>
                 <a:sym typeface="Assistant"/>
               </a:rPr>
@@ -19959,7 +19953,7 @@
                 <a:effectLst/>
                 <a:uLnTx/>
                 <a:uFillTx/>
-                <a:latin typeface="Arial" panose="020B[phone redacted]020204" pitchFamily="34" charset="0"/>
+                <a:latin typeface="Arial" panose="020B0604020202020204" pitchFamily="34" charset="0"/>
                 <a:cs typeface="Assistant"/>
                 <a:sym typeface="Assistant"/>
               </a:rPr>
@@ -19976,7 +19970,7 @@
                 <a:effectLst/>
                 <a:uLnTx/>
                 <a:uFillTx/>
-                <a:latin typeface="Arial" panose="020B[phone redacted]020204" pitchFamily="34" charset="0"/>
+                <a:latin typeface="Arial" panose="020B0604020202020204" pitchFamily="34" charset="0"/>
                 <a:cs typeface="Assistant"/>
                 <a:sym typeface="Assistant"/>
               </a:rPr>
@@ -19993,7 +19987,7 @@
                 <a:effectLst/>
                 <a:uLnTx/>
                 <a:uFillTx/>
-                <a:latin typeface="Arial" panose="020B[phone redacted]020204" pitchFamily="34" charset="0"/>
+                <a:latin typeface="Arial" panose="020B0604020202020204" pitchFamily="34" charset="0"/>
                 <a:cs typeface="Assistant"/>
                 <a:sym typeface="Assistant"/>
               </a:rPr>
@@ -20030,7 +20024,7 @@
               <a:effectLst/>
               <a:uLnTx/>
               <a:uFillTx/>
-              <a:latin typeface="Arial" panose="020B[phone redacted]020204" pitchFamily="34" charset="0"/>
+              <a:latin typeface="Arial" panose="020B0604020202020204" pitchFamily="34" charset="0"/>
               <a:cs typeface="Assistant"/>
               <a:sym typeface="Assistant"/>
             </a:endParaRPr>
@@ -20066,7 +20060,7 @@
                 <a:effectLst/>
                 <a:uLnTx/>
                 <a:uFillTx/>
-                <a:latin typeface="Arial" panose="020B[phone redacted]020204" pitchFamily="34" charset="0"/>
+                <a:latin typeface="Arial" panose="020B0604020202020204" pitchFamily="34" charset="0"/>
                 <a:cs typeface="Assistant"/>
                 <a:sym typeface="Assistant"/>
               </a:rPr>
@@ -20176,7 +20170,7 @@
                 <a:effectLst/>
                 <a:uLnTx/>
                 <a:uFillTx/>
-                <a:latin typeface="Arial" panose="020B[phone redacted]020204" pitchFamily="34" charset="0"/>
+                <a:latin typeface="Arial" panose="020B0604020202020204" pitchFamily="34" charset="0"/>
                 <a:cs typeface="Assistant"/>
                 <a:sym typeface="Assistant"/>
               </a:rPr>
@@ -20193,7 +20187,7 @@
                 <a:effectLst/>
                 <a:uLnTx/>
                 <a:uFillTx/>
-                <a:latin typeface="Arial" panose="020B[phone redacted]020204" pitchFamily="34" charset="0"/>
+                <a:latin typeface="Arial" panose="020B0604020202020204" pitchFamily="34" charset="0"/>
                 <a:cs typeface="Assistant"/>
                 <a:sym typeface="Assistant"/>
               </a:rPr>
@@ -20210,7 +20204,7 @@
                 <a:effectLst/>
                 <a:uLnTx/>
                 <a:uFillTx/>
-                <a:latin typeface="Arial" panose="020B[phone redacted]020204" pitchFamily="34" charset="0"/>
+                <a:latin typeface="Arial" panose="020B0604020202020204" pitchFamily="34" charset="0"/>
                 <a:cs typeface="Assistant"/>
                 <a:sym typeface="Assistant"/>
               </a:rPr>
@@ -20227,7 +20221,7 @@
                 <a:effectLst/>
                 <a:uLnTx/>
                 <a:uFillTx/>
-                <a:latin typeface="Arial" panose="020B[phone redacted]020204" pitchFamily="34" charset="0"/>
+                <a:latin typeface="Arial" panose="020B0604020202020204" pitchFamily="34" charset="0"/>
                 <a:cs typeface="Assistant"/>
                 <a:sym typeface="Assistant"/>
               </a:rPr>
@@ -20265,7 +20259,7 @@
                 <a:effectLst/>
                 <a:uLnTx/>
                 <a:uFillTx/>
-                <a:latin typeface="Arial" panose="020B[phone redacted]020204" pitchFamily="34" charset="0"/>
+                <a:latin typeface="Arial" panose="020B0604020202020204" pitchFamily="34" charset="0"/>
                 <a:cs typeface="Assistant"/>
                 <a:sym typeface="Assistant"/>
               </a:rPr>
@@ -20303,7 +20297,7 @@
                 <a:effectLst/>
                 <a:uLnTx/>
                 <a:uFillTx/>
-                <a:latin typeface="Arial" panose="020B[phone redacted]020204" pitchFamily="34" charset="0"/>
+                <a:latin typeface="Arial" panose="020B0604020202020204" pitchFamily="34" charset="0"/>
                 <a:cs typeface="Assistant"/>
                 <a:sym typeface="Assistant"/>
               </a:rPr>
@@ -20320,7 +20314,7 @@
                 <a:effectLst/>
                 <a:uLnTx/>
                 <a:uFillTx/>
-                <a:latin typeface="Arial" panose="020B[phone redacted]020204" pitchFamily="34" charset="0"/>
+                <a:latin typeface="Arial" panose="020B0604020202020204" pitchFamily="34" charset="0"/>
                 <a:cs typeface="Assistant"/>
                 <a:sym typeface="Assistant"/>
               </a:rPr>
@@ -20337,7 +20331,7 @@
                 <a:effectLst/>
                 <a:uLnTx/>
                 <a:uFillTx/>
-                <a:latin typeface="Arial" panose="020B[phone redacted]020204" pitchFamily="34" charset="0"/>
+                <a:latin typeface="Arial" panose="020B0604020202020204" pitchFamily="34" charset="0"/>
                 <a:cs typeface="Assistant"/>
                 <a:sym typeface="Assistant"/>
               </a:rPr>
@@ -20354,7 +20348,7 @@
                 <a:effectLst/>
                 <a:uLnTx/>
                 <a:uFillTx/>
-                <a:latin typeface="Arial" panose="020B[phone redacted]020204" pitchFamily="34" charset="0"/>
+                <a:latin typeface="Arial" panose="020B0604020202020204" pitchFamily="34" charset="0"/>
                 <a:cs typeface="Assistant"/>
                 <a:sym typeface="Assistant"/>
               </a:rPr>
@@ -20371,7 +20365,7 @@
                 <a:effectLst/>
                 <a:uLnTx/>
                 <a:uFillTx/>
-                <a:latin typeface="Arial" panose="020B[phone redacted]020204" pitchFamily="34" charset="0"/>
+                <a:latin typeface="Arial" panose="020B0604020202020204" pitchFamily="34" charset="0"/>
                 <a:cs typeface="Assistant"/>
                 <a:sym typeface="Assistant"/>
               </a:rPr>
@@ -20409,7 +20403,7 @@
                 <a:effectLst/>
                 <a:uLnTx/>
                 <a:uFillTx/>
-                <a:latin typeface="Arial" panose="020B[phone redacted]020204" pitchFamily="34" charset="0"/>
+                <a:latin typeface="Arial" panose="020B0604020202020204" pitchFamily="34" charset="0"/>
                 <a:cs typeface="Assistant"/>
                 <a:sym typeface="Assistant"/>
               </a:rPr>
@@ -20426,7 +20420,7 @@
                 <a:effectLst/>
                 <a:uLnTx/>
                 <a:uFillTx/>
-                <a:latin typeface="Arial" panose="020B[phone redacted]020204" pitchFamily="34" charset="0"/>
+                <a:latin typeface="Arial" panose="020B0604020202020204" pitchFamily="34" charset="0"/>
                 <a:cs typeface="Assistant"/>
                 <a:sym typeface="Assistant"/>
               </a:rPr>
@@ -20443,7 +20437,7 @@
                 <a:effectLst/>
                 <a:uLnTx/>
                 <a:uFillTx/>
-                <a:latin typeface="Arial" panose="020B[phone redacted]020204" pitchFamily="34" charset="0"/>
+                <a:latin typeface="Arial" panose="020B0604020202020204" pitchFamily="34" charset="0"/>
                 <a:cs typeface="Assistant"/>
                 <a:sym typeface="Assistant"/>
               </a:rPr>
@@ -20460,7 +20454,7 @@
                 <a:effectLst/>
                 <a:uLnTx/>
                 <a:uFillTx/>
-                <a:latin typeface="Arial" panose="020B[phone redacted]020204" pitchFamily="34" charset="0"/>
+                <a:latin typeface="Arial" panose="020B0604020202020204" pitchFamily="34" charset="0"/>
                 <a:cs typeface="Assistant"/>
                 <a:sym typeface="Assistant"/>
               </a:rPr>
@@ -20477,7 +20471,7 @@
                 <a:effectLst/>
                 <a:uLnTx/>
                 <a:uFillTx/>
-                <a:latin typeface="Arial" panose="020B[phone redacted]020204" pitchFamily="34" charset="0"/>
+                <a:latin typeface="Arial" panose="020B0604020202020204" pitchFamily="34" charset="0"/>
                 <a:cs typeface="Assistant"/>
                 <a:sym typeface="Assistant"/>
               </a:rPr>
@@ -20515,7 +20509,7 @@
                 <a:effectLst/>
                 <a:uLnTx/>
                 <a:uFillTx/>
-                <a:latin typeface="Arial" panose="020B[phone redacted]020204" pitchFamily="34" charset="0"/>
+                <a:latin typeface="Arial" panose="020B0604020202020204" pitchFamily="34" charset="0"/>
                 <a:cs typeface="Assistant"/>
                 <a:sym typeface="Assistant"/>
               </a:rPr>
@@ -20532,7 +20526,7 @@
                 <a:effectLst/>
                 <a:uLnTx/>
                 <a:uFillTx/>
-                <a:latin typeface="Arial" panose="020B[phone redacted]020204" pitchFamily="34" charset="0"/>
+                <a:latin typeface="Arial" panose="020B0604020202020204" pitchFamily="34" charset="0"/>
                 <a:cs typeface="Assistant"/>
                 <a:sym typeface="Assistant"/>
               </a:rPr>
@@ -20549,7 +20543,7 @@
                 <a:effectLst/>
                 <a:uLnTx/>
                 <a:uFillTx/>
-                <a:latin typeface="Arial" panose="020B[phone redacted]020204" pitchFamily="34" charset="0"/>
+                <a:latin typeface="Arial" panose="020B0604020202020204" pitchFamily="34" charset="0"/>
                 <a:cs typeface="Assistant"/>
                 <a:sym typeface="Assistant"/>
               </a:rPr>
@@ -20566,7 +20560,7 @@
                 <a:effectLst/>
                 <a:uLnTx/>
                 <a:uFillTx/>
-                <a:latin typeface="Arial" panose="020B[phone redacted]020204" pitchFamily="34" charset="0"/>
+                <a:latin typeface="Arial" panose="020B0604020202020204" pitchFamily="34" charset="0"/>
                 <a:cs typeface="Assistant"/>
                 <a:sym typeface="Assistant"/>
               </a:rPr>
@@ -20583,7 +20577,7 @@
                 <a:effectLst/>
                 <a:uLnTx/>
                 <a:uFillTx/>
-                <a:latin typeface="Arial" panose="020B[phone redacted]020204" pitchFamily="34" charset="0"/>
+                <a:latin typeface="Arial" panose="020B0604020202020204" pitchFamily="34" charset="0"/>
                 <a:cs typeface="Assistant"/>
                 <a:sym typeface="Assistant"/>
               </a:rPr>
@@ -20621,7 +20615,7 @@
                 <a:effectLst/>
                 <a:uLnTx/>
                 <a:uFillTx/>
-                <a:latin typeface="Arial" panose="020B[phone redacted]020204" pitchFamily="34" charset="0"/>
+                <a:latin typeface="Arial" panose="020B0604020202020204" pitchFamily="34" charset="0"/>
                 <a:cs typeface="Assistant"/>
                 <a:sym typeface="Assistant"/>
               </a:rPr>
@@ -20638,7 +20632,7 @@
                 <a:effectLst/>
                 <a:uLnTx/>
                 <a:uFillTx/>
-                <a:latin typeface="Arial" panose="020B[phone redacted]020204" pitchFamily="34" charset="0"/>
+                <a:latin typeface="Arial" panose="020B0604020202020204" pitchFamily="34" charset="0"/>
                 <a:cs typeface="Assistant"/>
                 <a:sym typeface="Assistant"/>
               </a:rPr>
@@ -20655,7 +20649,7 @@
                 <a:effectLst/>
                 <a:uLnTx/>
                 <a:uFillTx/>
-                <a:latin typeface="Arial" panose="020B[phone redacted]020204" pitchFamily="34" charset="0"/>
+                <a:latin typeface="Arial" panose="020B0604020202020204" pitchFamily="34" charset="0"/>
                 <a:cs typeface="Assistant"/>
                 <a:sym typeface="Assistant"/>
               </a:rPr>
@@ -20672,7 +20666,7 @@
                 <a:effectLst/>
                 <a:uLnTx/>
                 <a:uFillTx/>
-                <a:latin typeface="Arial" panose="020B[phone redacted]020204" pitchFamily="34" charset="0"/>
+                <a:latin typeface="Arial" panose="020B0604020202020204" pitchFamily="34" charset="0"/>
                 <a:cs typeface="Assistant"/>
                 <a:sym typeface="Assistant"/>
               </a:rPr>
@@ -20689,7 +20683,7 @@
                 <a:effectLst/>
                 <a:uLnTx/>
                 <a:uFillTx/>
-                <a:latin typeface="Arial" panose="020B[phone redacted]020204" pitchFamily="34" charset="0"/>
+                <a:latin typeface="Arial" panose="020B0604020202020204" pitchFamily="34" charset="0"/>
                 <a:cs typeface="Assistant"/>
                 <a:sym typeface="Assistant"/>
               </a:rPr>
@@ -20727,7 +20721,7 @@
                 <a:effectLst/>
                 <a:uLnTx/>
                 <a:uFillTx/>
-                <a:latin typeface="Arial" panose="020B[phone redacted]020204" pitchFamily="34" charset="0"/>
+                <a:latin typeface="Arial" panose="020B0604020202020204" pitchFamily="34" charset="0"/>
                 <a:cs typeface="Assistant"/>
                 <a:sym typeface="Assistant"/>
               </a:rPr>
@@ -20744,7 +20738,7 @@
                 <a:effectLst/>
                 <a:uLnTx/>
                 <a:uFillTx/>
-                <a:latin typeface="Arial" panose="020B[phone redacted]020204" pitchFamily="34" charset="0"/>
+                <a:latin typeface="Arial" panose="020B0604020202020204" pitchFamily="34" charset="0"/>
                 <a:cs typeface="Assistant"/>
                 <a:sym typeface="Assistant"/>
               </a:rPr>
@@ -20761,7 +20755,7 @@
                 <a:effectLst/>
                 <a:uLnTx/>
                 <a:uFillTx/>
-                <a:latin typeface="Arial" panose="020B[phone redacted]020204" pitchFamily="34" charset="0"/>
+                <a:latin typeface="Arial" panose="020B0604020202020204" pitchFamily="34" charset="0"/>
                 <a:cs typeface="Assistant"/>
                 <a:sym typeface="Assistant"/>
               </a:rPr>
@@ -20778,7 +20772,7 @@
                 <a:effectLst/>
                 <a:uLnTx/>
                 <a:uFillTx/>
-                <a:latin typeface="Arial" panose="020B[phone redacted]020204" pitchFamily="34" charset="0"/>
+                <a:latin typeface="Arial" panose="020B0604020202020204" pitchFamily="34" charset="0"/>
                 <a:cs typeface="Assistant"/>
                 <a:sym typeface="Assistant"/>
               </a:rPr>
@@ -20795,7 +20789,7 @@
                 <a:effectLst/>
                 <a:uLnTx/>
                 <a:uFillTx/>
-                <a:latin typeface="Arial" panose="020B[phone redacted]020204" pitchFamily="34" charset="0"/>
+                <a:latin typeface="Arial" panose="020B0604020202020204" pitchFamily="34" charset="0"/>
                 <a:cs typeface="Assistant"/>
                 <a:sym typeface="Assistant"/>
               </a:rPr>
@@ -20833,7 +20827,7 @@
                 <a:effectLst/>
                 <a:uLnTx/>
                 <a:uFillTx/>
-                <a:latin typeface="Arial" panose="020B[phone redacted]020204" pitchFamily="34" charset="0"/>
+                <a:latin typeface="Arial" panose="020B0604020202020204" pitchFamily="34" charset="0"/>
                 <a:cs typeface="Assistant"/>
                 <a:sym typeface="Assistant"/>
               </a:rPr>
@@ -20850,7 +20844,7 @@
                 <a:effectLst/>
                 <a:uLnTx/>
                 <a:uFillTx/>
-                <a:latin typeface="Arial" panose="020B[phone redacted]020204" pitchFamily="34" charset="0"/>
+                <a:latin typeface="Arial" panose="020B0604020202020204" pitchFamily="34" charset="0"/>
                 <a:cs typeface="Assistant"/>
                 <a:sym typeface="Assistant"/>
               </a:rPr>
@@ -20867,7 +20861,7 @@
                 <a:effectLst/>
                 <a:uLnTx/>
                 <a:uFillTx/>
-                <a:latin typeface="Arial" panose="020B[phone redacted]020204" pitchFamily="34" charset="0"/>
+                <a:latin typeface="Arial" panose="020B0604020202020204" pitchFamily="34" charset="0"/>
                 <a:cs typeface="Assistant"/>
                 <a:sym typeface="Assistant"/>
               </a:rPr>
@@ -20905,7 +20899,7 @@
                 <a:effectLst/>
                 <a:uLnTx/>
                 <a:uFillTx/>
-                <a:latin typeface="Arial" panose="020B[phone redacted]020204" pitchFamily="34" charset="0"/>
+                <a:latin typeface="Arial" panose="020B0604020202020204" pitchFamily="34" charset="0"/>
                 <a:cs typeface="Assistant"/>
                 <a:sym typeface="Assistant"/>
               </a:rPr>
@@ -20943,7 +20937,7 @@
                 <a:effectLst/>
                 <a:uLnTx/>
                 <a:uFillTx/>
-                <a:latin typeface="Arial" panose="020B[phone redacted]020204" pitchFamily="34" charset="0"/>
+                <a:latin typeface="Arial" panose="020B0604020202020204" pitchFamily="34" charset="0"/>
                 <a:cs typeface="Assistant"/>
                 <a:sym typeface="Assistant"/>
               </a:rPr>
@@ -20960,7 +20954,7 @@
                 <a:effectLst/>
                 <a:uLnTx/>
                 <a:uFillTx/>
-                <a:latin typeface="Arial" panose="020B[phone redacted]020204" pitchFamily="34" charset="0"/>
+                <a:latin typeface="Arial" panose="020B0604020202020204" pitchFamily="34" charset="0"/>
                 <a:cs typeface="Assistant"/>
                 <a:sym typeface="Assistant"/>
               </a:rPr>
@@ -20977,7 +20971,7 @@
                 <a:effectLst/>
                 <a:uLnTx/>
                 <a:uFillTx/>
-                <a:latin typeface="Arial" panose="020B[phone redacted]020204" pitchFamily="34" charset="0"/>
+                <a:latin typeface="Arial" panose="020B0604020202020204" pitchFamily="34" charset="0"/>
                 <a:cs typeface="Assistant"/>
                 <a:sym typeface="Assistant"/>
               </a:rPr>
@@ -20994,7 +20988,7 @@
                 <a:effectLst/>
                 <a:uLnTx/>
                 <a:uFillTx/>
-                <a:latin typeface="Arial" panose="020B[phone redacted]020204" pitchFamily="34" charset="0"/>
+                <a:latin typeface="Arial" panose="020B0604020202020204" pitchFamily="34" charset="0"/>
                 <a:cs typeface="Assistant"/>
                 <a:sym typeface="Assistant"/>
               </a:rPr>
@@ -21011,7 +21005,7 @@
                 <a:effectLst/>
                 <a:uLnTx/>
                 <a:uFillTx/>
-                <a:latin typeface="Arial" panose="020B[phone redacted]020204" pitchFamily="34" charset="0"/>
+                <a:latin typeface="Arial" panose="020B0604020202020204" pitchFamily="34" charset="0"/>
                 <a:cs typeface="Assistant"/>
                 <a:sym typeface="Assistant"/>
               </a:rPr>
@@ -21049,7 +21043,7 @@
                 <a:effectLst/>
                 <a:uLnTx/>
                 <a:uFillTx/>
-                <a:latin typeface="Arial" panose="020B[phone redacted]020204" pitchFamily="34" charset="0"/>
+                <a:latin typeface="Arial" panose="020B0604020202020204" pitchFamily="34" charset="0"/>
                 <a:cs typeface="Assistant"/>
                 <a:sym typeface="Assistant"/>
               </a:rPr>
@@ -21066,7 +21060,7 @@
                 <a:effectLst/>
                 <a:uLnTx/>
                 <a:uFillTx/>
-                <a:latin typeface="Arial" panose="020B[phone redacted]020204" pitchFamily="34" charset="0"/>
+                <a:latin typeface="Arial" panose="020B0604020202020204" pitchFamily="34" charset="0"/>
                 <a:cs typeface="Assistant"/>
                 <a:sym typeface="Assistant"/>
               </a:rPr>
@@ -21083,7 +21077,7 @@
                 <a:effectLst/>
                 <a:uLnTx/>
                 <a:uFillTx/>
-                <a:latin typeface="Arial" panose="020B[phone redacted]020204" pitchFamily="34" charset="0"/>
+                <a:latin typeface="Arial" panose="020B0604020202020204" pitchFamily="34" charset="0"/>
                 <a:cs typeface="Assistant"/>
                 <a:sym typeface="Assistant"/>
               </a:rPr>
@@ -21121,7 +21115,7 @@
                 <a:effectLst/>
                 <a:uLnTx/>
                 <a:uFillTx/>
-                <a:latin typeface="Arial" panose="020B[phone redacted]020204" pitchFamily="34" charset="0"/>
+                <a:latin typeface="Arial" panose="020B0604020202020204" pitchFamily="34" charset="0"/>
                 <a:cs typeface="Assistant"/>
                 <a:sym typeface="Assistant"/>
               </a:rPr>
@@ -21138,7 +21132,7 @@
                 <a:effectLst/>
                 <a:uLnTx/>
                 <a:uFillTx/>
-                <a:latin typeface="Arial" panose="020B[phone redacted]020204" pitchFamily="34" charset="0"/>
+                <a:latin typeface="Arial" panose="020B0604020202020204" pitchFamily="34" charset="0"/>
                 <a:cs typeface="Assistant"/>
                 <a:sym typeface="Assistant"/>
               </a:rPr>
@@ -21155,7 +21149,7 @@
                 <a:effectLst/>
                 <a:uLnTx/>
                 <a:uFillTx/>
-                <a:latin typeface="Arial" panose="020B[phone redacted]020204" pitchFamily="34" charset="0"/>
+                <a:latin typeface="Arial" panose="020B0604020202020204" pitchFamily="34" charset="0"/>
                 <a:cs typeface="Assistant"/>
                 <a:sym typeface="Assistant"/>
               </a:rPr>
@@ -21193,7 +21187,7 @@
                 <a:effectLst/>
                 <a:uLnTx/>
                 <a:uFillTx/>
-                <a:latin typeface="Arial" panose="020B[phone redacted]020204" pitchFamily="34" charset="0"/>
+                <a:latin typeface="Arial" panose="020B0604020202020204" pitchFamily="34" charset="0"/>
                 <a:cs typeface="Assistant"/>
                 <a:sym typeface="Assistant"/>
               </a:rPr>
@@ -21210,7 +21204,7 @@
                 <a:effectLst/>
                 <a:uLnTx/>
                 <a:uFillTx/>
-                <a:latin typeface="Arial" panose="020B[phone redacted]020204" pitchFamily="34" charset="0"/>
+                <a:latin typeface="Arial" panose="020B0604020202020204" pitchFamily="34" charset="0"/>
                 <a:cs typeface="Assistant"/>
                 <a:sym typeface="Assistant"/>
               </a:rPr>
@@ -21227,7 +21221,7 @@
                 <a:effectLst/>
                 <a:uLnTx/>
                 <a:uFillTx/>
-                <a:latin typeface="Arial" panose="020B[phone redacted]020204" pitchFamily="34" charset="0"/>
+                <a:latin typeface="Arial" panose="020B0604020202020204" pitchFamily="34" charset="0"/>
                 <a:cs typeface="Assistant"/>
                 <a:sym typeface="Assistant"/>
               </a:rPr>
@@ -21264,7 +21258,7 @@
               <a:effectLst/>
               <a:uLnTx/>
               <a:uFillTx/>
-              <a:latin typeface="Arial" panose="020B[phone redacted]020204" pitchFamily="34" charset="0"/>
+              <a:latin typeface="Arial" panose="020B0604020202020204" pitchFamily="34" charset="0"/>
               <a:cs typeface="Assistant"/>
               <a:sym typeface="Assistant"/>
             </a:endParaRPr>
@@ -21300,7 +21294,7 @@
                 <a:effectLst/>
                 <a:uLnTx/>
                 <a:uFillTx/>
-                <a:latin typeface="Arial" panose="020B[phone redacted]020204" pitchFamily="34" charset="0"/>
+                <a:latin typeface="Arial" panose="020B0604020202020204" pitchFamily="34" charset="0"/>
                 <a:cs typeface="Assistant"/>
                 <a:sym typeface="Assistant"/>
               </a:rPr>
@@ -21317,7 +21311,7 @@
                 <a:effectLst/>
                 <a:uLnTx/>
                 <a:uFillTx/>
-                <a:latin typeface="Arial" panose="020B[phone redacted]020204" pitchFamily="34" charset="0"/>
+                <a:latin typeface="Arial" panose="020B0604020202020204" pitchFamily="34" charset="0"/>
                 <a:cs typeface="Assistant"/>
                 <a:sym typeface="Assistant"/>
               </a:rPr>
@@ -21355,7 +21349,7 @@
                 <a:effectLst/>
                 <a:uLnTx/>
                 <a:uFillTx/>
-                <a:latin typeface="Arial" panose="020B[phone redacted]020204" pitchFamily="34" charset="0"/>
+                <a:latin typeface="Arial" panose="020B0604020202020204" pitchFamily="34" charset="0"/>
                 <a:cs typeface="Assistant"/>
                 <a:sym typeface="Assistant"/>
               </a:rPr>
@@ -21372,7 +21366,7 @@
                 <a:effectLst/>
                 <a:uLnTx/>
                 <a:uFillTx/>
-                <a:latin typeface="Arial" panose="020B[phone redacted]020204" pitchFamily="34" charset="0"/>
+                <a:latin typeface="Arial" panose="020B0604020202020204" pitchFamily="34" charset="0"/>
                 <a:cs typeface="Assistant"/>
                 <a:sym typeface="Assistant"/>
               </a:rPr>
@@ -21389,7 +21383,7 @@
                 <a:effectLst/>
                 <a:uLnTx/>
                 <a:uFillTx/>
-                <a:latin typeface="Arial" panose="020B[phone redacted]020204" pitchFamily="34" charset="0"/>
+                <a:latin typeface="Arial" panose="020B0604020202020204" pitchFamily="34" charset="0"/>
                 <a:cs typeface="Assistant"/>
                 <a:sym typeface="Assistant"/>
               </a:rPr>
@@ -21427,7 +21421,7 @@
                 <a:effectLst/>
                 <a:uLnTx/>
                 <a:uFillTx/>
-                <a:latin typeface="Arial" panose="020B[phone redacted]020204" pitchFamily="34" charset="0"/>
+                <a:latin typeface="Arial" panose="020B0604020202020204" pitchFamily="34" charset="0"/>
                 <a:cs typeface="Assistant"/>
                 <a:sym typeface="Assistant"/>
               </a:rPr>
@@ -21444,7 +21438,7 @@
                 <a:effectLst/>
                 <a:uLnTx/>
                 <a:uFillTx/>
-                <a:latin typeface="Arial" panose="020B[phone redacted]020204" pitchFamily="34" charset="0"/>
+                <a:latin typeface="Arial" panose="020B0604020202020204" pitchFamily="34" charset="0"/>
                 <a:cs typeface="Assistant"/>
                 <a:sym typeface="Assistant"/>
               </a:rPr>
@@ -21461,7 +21455,7 @@
                 <a:effectLst/>
                 <a:uLnTx/>
                 <a:uFillTx/>
-                <a:latin typeface="Arial" panose="020B[phone redacted]020204" pitchFamily="34" charset="0"/>
+                <a:latin typeface="Arial" panose="020B0604020202020204" pitchFamily="34" charset="0"/>
                 <a:cs typeface="Assistant"/>
                 <a:sym typeface="Assistant"/>
               </a:rPr>
@@ -21499,7 +21493,7 @@
                 <a:effectLst/>
                 <a:uLnTx/>
                 <a:uFillTx/>
-                <a:latin typeface="Arial" panose="020B[phone redacted]020204" pitchFamily="34" charset="0"/>
+                <a:latin typeface="Arial" panose="020B0604020202020204" pitchFamily="34" charset="0"/>
                 <a:cs typeface="Assistant"/>
                 <a:sym typeface="Assistant"/>
               </a:rPr>
@@ -21516,7 +21510,7 @@
                 <a:effectLst/>
                 <a:uLnTx/>
                 <a:uFillTx/>
-                <a:latin typeface="Arial" panose="020B[phone redacted]020204" pitchFamily="34" charset="0"/>
+                <a:latin typeface="Arial" panose="020B0604020202020204" pitchFamily="34" charset="0"/>
                 <a:cs typeface="Assistant"/>
                 <a:sym typeface="Assistant"/>
               </a:rPr>
@@ -21533,7 +21527,7 @@
                 <a:effectLst/>
                 <a:uLnTx/>
                 <a:uFillTx/>
-                <a:latin typeface="Arial" panose="020B[phone redacted]020204" pitchFamily="34" charset="0"/>
+                <a:latin typeface="Arial" panose="020B0604020202020204" pitchFamily="34" charset="0"/>
                 <a:cs typeface="Assistant"/>
                 <a:sym typeface="Assistant"/>
               </a:rPr>
@@ -21571,7 +21565,7 @@
                 <a:effectLst/>
                 <a:uLnTx/>
                 <a:uFillTx/>
-                <a:latin typeface="Arial" panose="020B[phone redacted]020204" pitchFamily="34" charset="0"/>
+                <a:latin typeface="Arial" panose="020B0604020202020204" pitchFamily="34" charset="0"/>
                 <a:cs typeface="Assistant"/>
                 <a:sym typeface="Assistant"/>
               </a:rPr>
@@ -21588,7 +21582,7 @@
                 <a:effectLst/>
                 <a:uLnTx/>
                 <a:uFillTx/>
-                <a:latin typeface="Arial" panose="020B[phone redacted]020204" pitchFamily="34" charset="0"/>
+                <a:latin typeface="Arial" panose="020B0604020202020204" pitchFamily="34" charset="0"/>
                 <a:cs typeface="Assistant"/>
                 <a:sym typeface="Assistant"/>
               </a:rPr>
@@ -21605,7 +21599,7 @@
                 <a:effectLst/>
                 <a:uLnTx/>
                 <a:uFillTx/>
-                <a:latin typeface="Arial" panose="020B[phone redacted]020204" pitchFamily="34" charset="0"/>
+                <a:latin typeface="Arial" panose="020B0604020202020204" pitchFamily="34" charset="0"/>
                 <a:cs typeface="Assistant"/>
                 <a:sym typeface="Assistant"/>
               </a:rPr>
@@ -21637,7 +21631,7 @@
                 <a:solidFill>
                   <a:srgbClr val="FFFFFF"/>
                 </a:solidFill>
-                <a:latin typeface="Arial" panose="020B[phone redacted]020204" pitchFamily="34" charset="0"/>
+                <a:latin typeface="Arial" panose="020B0604020202020204" pitchFamily="34" charset="0"/>
                 <a:cs typeface="Assistant"/>
                 <a:sym typeface="Assistant"/>
               </a:rPr>
@@ -21654,7 +21648,7 @@
                 <a:effectLst/>
                 <a:uLnTx/>
                 <a:uFillTx/>
-                <a:latin typeface="Arial" panose="020B[phone redacted]020204" pitchFamily="34" charset="0"/>
+                <a:latin typeface="Arial" panose="020B0604020202020204" pitchFamily="34" charset="0"/>
                 <a:cs typeface="Assistant"/>
                 <a:sym typeface="Assistant"/>
               </a:rPr>
@@ -21671,7 +21665,7 @@
                 <a:effectLst/>
                 <a:uLnTx/>
                 <a:uFillTx/>
-                <a:latin typeface="Arial" panose="020B[phone redacted]020204" pitchFamily="34" charset="0"/>
+                <a:latin typeface="Arial" panose="020B0604020202020204" pitchFamily="34" charset="0"/>
                 <a:cs typeface="Assistant"/>
                 <a:sym typeface="Assistant"/>
               </a:rPr>
@@ -21709,7 +21703,7 @@
                 <a:effectLst/>
                 <a:uLnTx/>
                 <a:uFillTx/>
-                <a:latin typeface="Arial" panose="020B[phone redacted]020204" pitchFamily="34" charset="0"/>
+                <a:latin typeface="Arial" panose="020B0604020202020204" pitchFamily="34" charset="0"/>
                 <a:cs typeface="Assistant"/>
                 <a:sym typeface="Assistant"/>
               </a:rPr>
@@ -22230,7 +22224,7 @@
         <p:spPr>
           <a:xfrm>
             <a:off x="3434079" y="535081"/>
-            <a:ext cx="5787813" cy="523220"/>
+            <a:ext cx="5787813" cy="307777"/>
           </a:xfrm>
           <a:prstGeom prst="rect">
             <a:avLst/>
@@ -22244,17 +22238,10 @@
           <a:lstStyle/>
           <a:p>
             <a:r>
-              <a:rPr lang="fr-FR" dirty="0">
+              <a:rPr lang="fr-FR">
                 <a:solidFill>
                   <a:schemeClr val="accent6"/>
                 </a:solidFill>
-                <a:hlinkClick r:id="rId4">
-                  <a:extLst>
-                    <a:ext uri="{A12FA001-AC4F-418D-AE19-62706E023703}">
-                      <ahyp:hlinkClr xmlns:ahyp="http://schemas.microsoft.com/office/drawing/2018/hyperlinkcolor" val="tx"/>
-                    </a:ext>
-                  </a:extLst>
-                </a:hlinkClick>
               </a:rPr>
               <a:t>https://www.tinkercad.com/</a:t>
             </a:r>
@@ -22477,21 +22464,24 @@
                 <a:effectLst/>
                 <a:latin typeface="artifakt-element"/>
               </a:rPr>
-              <a:t>Allumer une LED avec un bouton poussoir: </a:t>
+              <a:t>Allumer une LED avec un bouton poussoir</a:t>
             </a:r>
             <a:r>
-              <a:rPr lang="fr-FR" b="1" dirty="0">
+              <a:rPr lang="fr-FR" b="1">
+                <a:solidFill>
+                  <a:schemeClr val="bg1"/>
+                </a:solidFill>
+                <a:effectLst/>
+                <a:latin typeface="artifakt-element"/>
+              </a:rPr>
+              <a:t>: </a:t>
+            </a:r>
+            <a:r>
+              <a:rPr lang="fr-FR" b="1">
                 <a:solidFill>
                   <a:schemeClr val="accent6"/>
                 </a:solidFill>
                 <a:latin typeface="+mn-lt"/>
-                <a:hlinkClick r:id="rId2">
-                  <a:extLst>
-                    <a:ext uri="{A12FA001-AC4F-418D-AE19-62706E023703}">
-                      <ahyp:hlinkClr xmlns:ahyp="http://schemas.microsoft.com/office/drawing/2018/hyperlinkcolor" val="tx"/>
-                    </a:ext>
-                  </a:extLst>
-                </a:hlinkClick>
               </a:rPr>
               <a:t>https://www.tinkercad.com/</a:t>
             </a:r>
@@ -22532,18 +22522,11 @@
               <a:buNone/>
             </a:pPr>
             <a:r>
-              <a:rPr lang="fr-FR" b="1" dirty="0">
+              <a:rPr lang="fr-FR" b="1">
                 <a:solidFill>
                   <a:schemeClr val="accent6"/>
                 </a:solidFill>
                 <a:latin typeface="+mn-lt"/>
-                <a:hlinkClick r:id="rId3">
-                  <a:extLst>
-                    <a:ext uri="{A12FA001-AC4F-418D-AE19-62706E023703}">
-                      <ahyp:hlinkClr xmlns:ahyp="http://schemas.microsoft.com/office/drawing/2018/hyperlinkcolor" val="tx"/>
-                    </a:ext>
-                  </a:extLst>
-                </a:hlinkClick>
               </a:rPr>
               <a:t>https://www.tinkercad.com/</a:t>
             </a:r>

</xml_diff>

<commit_message>
restore: original project presentation
</commit_message>
<xml_diff>
--- a/presentations/mobile-robot-presentation-fr.pptx
+++ b/presentations/mobile-robot-presentation-fr.pptx
@@ -1,6 +1,6 @@
 
 <file path=ppt/presentation.xml><?xml version="1.0" encoding="utf-8"?>
-<p:presentation xmlns:a="http://schemas.openxmlformats.org/drawingml/2006/main" xmlns:r="http://schemas.openxmlformats.org/officeDocument/2006/relationships" xmlns:p="http://schemas.openxmlformats.org/presentationml/2006/main" removePersonalInfoOnSave="1" strictFirstAndLastChars="0" saveSubsetFonts="1" autoCompressPictures="0">
+<p:presentation xmlns:a="http://schemas.openxmlformats.org/drawingml/2006/main" xmlns:r="http://schemas.openxmlformats.org/officeDocument/2006/relationships" xmlns:p="http://schemas.openxmlformats.org/presentationml/2006/main" strictFirstAndLastChars="0" saveSubsetFonts="1" autoCompressPictures="0">
   <p:sldMasterIdLst>
     <p:sldMasterId id="2147483679" r:id="rId1"/>
   </p:sldMasterIdLst>
@@ -275,7 +275,13 @@
 
 <file path=ppt/commentAuthors.xml><?xml version="1.0" encoding="utf-8"?>
 <p:cmAuthorLst xmlns:a="http://schemas.openxmlformats.org/drawingml/2006/main" xmlns:r="http://schemas.openxmlformats.org/officeDocument/2006/relationships" xmlns:p="http://schemas.openxmlformats.org/presentationml/2006/main">
-  <p:cmAuthor id="2" name="Auteur" initials="A" lastIdx="0" clrIdx="1"/>
+  <p:cmAuthor id="1" name="EL AKKAOUI ADAM" initials="EAA" lastIdx="1" clrIdx="0">
+    <p:extLst>
+      <p:ext uri="{19B8F6BF-5375-455C-9EA6-DF929625EA0E}">
+        <p15:presenceInfo xmlns:p15="http://schemas.microsoft.com/office/powerpoint/2012/main" userId="EL AKKAOUI ADAM" providerId="None"/>
+      </p:ext>
+    </p:extLst>
+  </p:cmAuthor>
 </p:cmAuthorLst>
 </file>
 
@@ -18709,7 +18715,7 @@
                 <a:solidFill>
                   <a:schemeClr val="accent6"/>
                 </a:solidFill>
-                <a:latin typeface="Georgia" panose="02040502050405020303" pitchFamily="18" charset="0"/>
+                <a:latin typeface="Georgia" panose="0204[phone redacted]020303" pitchFamily="18" charset="0"/>
               </a:rPr>
               <a:t>C</a:t>
             </a:r>
@@ -18719,7 +18725,7 @@
                   <a:schemeClr val="accent6"/>
                 </a:solidFill>
                 <a:effectLst/>
-                <a:latin typeface="Georgia" panose="02040502050405020303" pitchFamily="18" charset="0"/>
+                <a:latin typeface="Georgia" panose="0204[phone redacted]020303" pitchFamily="18" charset="0"/>
               </a:rPr>
               <a:t>ircuit du robot mobile</a:t>
             </a:r>
@@ -18809,7 +18815,7 @@
                 <a:effectLst/>
                 <a:uLnTx/>
                 <a:uFillTx/>
-                <a:latin typeface="Arial" panose="020B0604020202020204" pitchFamily="34" charset="0"/>
+                <a:latin typeface="Arial" panose="020B[phone redacted]020204" pitchFamily="34" charset="0"/>
                 <a:cs typeface="Assistant"/>
                 <a:sym typeface="Assistant"/>
               </a:rPr>
@@ -18826,7 +18832,7 @@
                 <a:effectLst/>
                 <a:uLnTx/>
                 <a:uFillTx/>
-                <a:latin typeface="Arial" panose="020B0604020202020204" pitchFamily="34" charset="0"/>
+                <a:latin typeface="Arial" panose="020B[phone redacted]020204" pitchFamily="34" charset="0"/>
                 <a:cs typeface="Assistant"/>
                 <a:sym typeface="Assistant"/>
               </a:rPr>
@@ -18843,7 +18849,7 @@
                 <a:effectLst/>
                 <a:uLnTx/>
                 <a:uFillTx/>
-                <a:latin typeface="Arial" panose="020B0604020202020204" pitchFamily="34" charset="0"/>
+                <a:latin typeface="Arial" panose="020B[phone redacted]020204" pitchFamily="34" charset="0"/>
                 <a:cs typeface="Assistant"/>
                 <a:sym typeface="Assistant"/>
               </a:rPr>
@@ -18880,7 +18886,7 @@
               <a:effectLst/>
               <a:uLnTx/>
               <a:uFillTx/>
-              <a:latin typeface="Arial" panose="020B0604020202020204" pitchFamily="34" charset="0"/>
+              <a:latin typeface="Arial" panose="020B[phone redacted]020204" pitchFamily="34" charset="0"/>
               <a:cs typeface="Assistant"/>
               <a:sym typeface="Assistant"/>
             </a:endParaRPr>
@@ -18916,7 +18922,7 @@
                 <a:effectLst/>
                 <a:uLnTx/>
                 <a:uFillTx/>
-                <a:latin typeface="Arial" panose="020B0604020202020204" pitchFamily="34" charset="0"/>
+                <a:latin typeface="Arial" panose="020B[phone redacted]020204" pitchFamily="34" charset="0"/>
                 <a:cs typeface="Assistant"/>
                 <a:sym typeface="Assistant"/>
               </a:rPr>
@@ -18933,7 +18939,7 @@
                 <a:effectLst/>
                 <a:uLnTx/>
                 <a:uFillTx/>
-                <a:latin typeface="Arial" panose="020B0604020202020204" pitchFamily="34" charset="0"/>
+                <a:latin typeface="Arial" panose="020B[phone redacted]020204" pitchFamily="34" charset="0"/>
                 <a:cs typeface="Assistant"/>
                 <a:sym typeface="Assistant"/>
               </a:rPr>
@@ -18944,7 +18950,7 @@
                 <a:solidFill>
                   <a:srgbClr val="FFFFFF"/>
                 </a:solidFill>
-                <a:latin typeface="Arial" panose="020B0604020202020204" pitchFamily="34" charset="0"/>
+                <a:latin typeface="Arial" panose="020B[phone redacted]020204" pitchFamily="34" charset="0"/>
                 <a:cs typeface="Assistant"/>
                 <a:sym typeface="Assistant"/>
               </a:rPr>
@@ -18961,7 +18967,7 @@
                 <a:effectLst/>
                 <a:uLnTx/>
                 <a:uFillTx/>
-                <a:latin typeface="Arial" panose="020B0604020202020204" pitchFamily="34" charset="0"/>
+                <a:latin typeface="Arial" panose="020B[phone redacted]020204" pitchFamily="34" charset="0"/>
                 <a:cs typeface="Assistant"/>
                 <a:sym typeface="Assistant"/>
               </a:rPr>
@@ -18999,7 +19005,7 @@
                 <a:effectLst/>
                 <a:uLnTx/>
                 <a:uFillTx/>
-                <a:latin typeface="Arial" panose="020B0604020202020204" pitchFamily="34" charset="0"/>
+                <a:latin typeface="Arial" panose="020B[phone redacted]020204" pitchFamily="34" charset="0"/>
                 <a:cs typeface="Assistant"/>
                 <a:sym typeface="Assistant"/>
               </a:rPr>
@@ -19016,7 +19022,7 @@
                 <a:effectLst/>
                 <a:uLnTx/>
                 <a:uFillTx/>
-                <a:latin typeface="Arial" panose="020B0604020202020204" pitchFamily="34" charset="0"/>
+                <a:latin typeface="Arial" panose="020B[phone redacted]020204" pitchFamily="34" charset="0"/>
                 <a:cs typeface="Assistant"/>
                 <a:sym typeface="Assistant"/>
               </a:rPr>
@@ -19027,7 +19033,7 @@
                 <a:solidFill>
                   <a:srgbClr val="FFFFFF"/>
                 </a:solidFill>
-                <a:latin typeface="Arial" panose="020B0604020202020204" pitchFamily="34" charset="0"/>
+                <a:latin typeface="Arial" panose="020B[phone redacted]020204" pitchFamily="34" charset="0"/>
                 <a:cs typeface="Assistant"/>
                 <a:sym typeface="Assistant"/>
               </a:rPr>
@@ -19044,7 +19050,7 @@
                 <a:effectLst/>
                 <a:uLnTx/>
                 <a:uFillTx/>
-                <a:latin typeface="Arial" panose="020B0604020202020204" pitchFamily="34" charset="0"/>
+                <a:latin typeface="Arial" panose="020B[phone redacted]020204" pitchFamily="34" charset="0"/>
                 <a:cs typeface="Assistant"/>
                 <a:sym typeface="Assistant"/>
               </a:rPr>
@@ -19082,7 +19088,7 @@
                 <a:effectLst/>
                 <a:uLnTx/>
                 <a:uFillTx/>
-                <a:latin typeface="Arial" panose="020B0604020202020204" pitchFamily="34" charset="0"/>
+                <a:latin typeface="Arial" panose="020B[phone redacted]020204" pitchFamily="34" charset="0"/>
                 <a:cs typeface="Assistant"/>
                 <a:sym typeface="Assistant"/>
               </a:rPr>
@@ -19099,7 +19105,7 @@
                 <a:effectLst/>
                 <a:uLnTx/>
                 <a:uFillTx/>
-                <a:latin typeface="Arial" panose="020B0604020202020204" pitchFamily="34" charset="0"/>
+                <a:latin typeface="Arial" panose="020B[phone redacted]020204" pitchFamily="34" charset="0"/>
                 <a:cs typeface="Assistant"/>
                 <a:sym typeface="Assistant"/>
               </a:rPr>
@@ -19116,7 +19122,7 @@
                 <a:effectLst/>
                 <a:uLnTx/>
                 <a:uFillTx/>
-                <a:latin typeface="Arial" panose="020B0604020202020204" pitchFamily="34" charset="0"/>
+                <a:latin typeface="Arial" panose="020B[phone redacted]020204" pitchFamily="34" charset="0"/>
                 <a:cs typeface="Assistant"/>
                 <a:sym typeface="Assistant"/>
               </a:rPr>
@@ -19154,7 +19160,7 @@
                 <a:effectLst/>
                 <a:uLnTx/>
                 <a:uFillTx/>
-                <a:latin typeface="Arial" panose="020B0604020202020204" pitchFamily="34" charset="0"/>
+                <a:latin typeface="Arial" panose="020B[phone redacted]020204" pitchFamily="34" charset="0"/>
                 <a:cs typeface="Assistant"/>
                 <a:sym typeface="Assistant"/>
               </a:rPr>
@@ -19171,7 +19177,7 @@
                 <a:effectLst/>
                 <a:uLnTx/>
                 <a:uFillTx/>
-                <a:latin typeface="Arial" panose="020B0604020202020204" pitchFamily="34" charset="0"/>
+                <a:latin typeface="Arial" panose="020B[phone redacted]020204" pitchFamily="34" charset="0"/>
                 <a:cs typeface="Assistant"/>
                 <a:sym typeface="Assistant"/>
               </a:rPr>
@@ -19188,7 +19194,7 @@
                 <a:effectLst/>
                 <a:uLnTx/>
                 <a:uFillTx/>
-                <a:latin typeface="Arial" panose="020B0604020202020204" pitchFamily="34" charset="0"/>
+                <a:latin typeface="Arial" panose="020B[phone redacted]020204" pitchFamily="34" charset="0"/>
                 <a:cs typeface="Assistant"/>
                 <a:sym typeface="Assistant"/>
               </a:rPr>
@@ -19199,7 +19205,7 @@
                 <a:solidFill>
                   <a:schemeClr val="accent4"/>
                 </a:solidFill>
-                <a:latin typeface="Arial" panose="020B0604020202020204" pitchFamily="34" charset="0"/>
+                <a:latin typeface="Arial" panose="020B[phone redacted]020204" pitchFamily="34" charset="0"/>
                 <a:cs typeface="Assistant"/>
                 <a:sym typeface="Assistant"/>
               </a:rPr>
@@ -19216,7 +19222,7 @@
                 <a:effectLst/>
                 <a:uLnTx/>
                 <a:uFillTx/>
-                <a:latin typeface="Arial" panose="020B0604020202020204" pitchFamily="34" charset="0"/>
+                <a:latin typeface="Arial" panose="020B[phone redacted]020204" pitchFamily="34" charset="0"/>
                 <a:cs typeface="Assistant"/>
                 <a:sym typeface="Assistant"/>
               </a:rPr>
@@ -19254,7 +19260,7 @@
                 <a:effectLst/>
                 <a:uLnTx/>
                 <a:uFillTx/>
-                <a:latin typeface="Arial" panose="020B0604020202020204" pitchFamily="34" charset="0"/>
+                <a:latin typeface="Arial" panose="020B[phone redacted]020204" pitchFamily="34" charset="0"/>
                 <a:cs typeface="Assistant"/>
                 <a:sym typeface="Assistant"/>
               </a:rPr>
@@ -19271,7 +19277,7 @@
                 <a:effectLst/>
                 <a:uLnTx/>
                 <a:uFillTx/>
-                <a:latin typeface="Arial" panose="020B0604020202020204" pitchFamily="34" charset="0"/>
+                <a:latin typeface="Arial" panose="020B[phone redacted]020204" pitchFamily="34" charset="0"/>
                 <a:cs typeface="Assistant"/>
                 <a:sym typeface="Assistant"/>
               </a:rPr>
@@ -19288,7 +19294,7 @@
                 <a:effectLst/>
                 <a:uLnTx/>
                 <a:uFillTx/>
-                <a:latin typeface="Arial" panose="020B0604020202020204" pitchFamily="34" charset="0"/>
+                <a:latin typeface="Arial" panose="020B[phone redacted]020204" pitchFamily="34" charset="0"/>
                 <a:cs typeface="Assistant"/>
                 <a:sym typeface="Assistant"/>
               </a:rPr>
@@ -19326,7 +19332,7 @@
                 <a:effectLst/>
                 <a:uLnTx/>
                 <a:uFillTx/>
-                <a:latin typeface="Arial" panose="020B0604020202020204" pitchFamily="34" charset="0"/>
+                <a:latin typeface="Arial" panose="020B[phone redacted]020204" pitchFamily="34" charset="0"/>
                 <a:cs typeface="Assistant"/>
                 <a:sym typeface="Assistant"/>
               </a:rPr>
@@ -19343,7 +19349,7 @@
                 <a:effectLst/>
                 <a:uLnTx/>
                 <a:uFillTx/>
-                <a:latin typeface="Arial" panose="020B0604020202020204" pitchFamily="34" charset="0"/>
+                <a:latin typeface="Arial" panose="020B[phone redacted]020204" pitchFamily="34" charset="0"/>
                 <a:cs typeface="Assistant"/>
                 <a:sym typeface="Assistant"/>
               </a:rPr>
@@ -19354,7 +19360,7 @@
                 <a:solidFill>
                   <a:srgbClr val="FFFFFF"/>
                 </a:solidFill>
-                <a:latin typeface="Arial" panose="020B0604020202020204" pitchFamily="34" charset="0"/>
+                <a:latin typeface="Arial" panose="020B[phone redacted]020204" pitchFamily="34" charset="0"/>
                 <a:cs typeface="Assistant"/>
                 <a:sym typeface="Assistant"/>
               </a:rPr>
@@ -19371,7 +19377,7 @@
                 <a:effectLst/>
                 <a:uLnTx/>
                 <a:uFillTx/>
-                <a:latin typeface="Arial" panose="020B0604020202020204" pitchFamily="34" charset="0"/>
+                <a:latin typeface="Arial" panose="020B[phone redacted]020204" pitchFamily="34" charset="0"/>
                 <a:cs typeface="Assistant"/>
                 <a:sym typeface="Assistant"/>
               </a:rPr>
@@ -19409,7 +19415,7 @@
                 <a:effectLst/>
                 <a:uLnTx/>
                 <a:uFillTx/>
-                <a:latin typeface="Arial" panose="020B0604020202020204" pitchFamily="34" charset="0"/>
+                <a:latin typeface="Arial" panose="020B[phone redacted]020204" pitchFamily="34" charset="0"/>
                 <a:cs typeface="Assistant"/>
                 <a:sym typeface="Assistant"/>
               </a:rPr>
@@ -19426,7 +19432,7 @@
                 <a:effectLst/>
                 <a:uLnTx/>
                 <a:uFillTx/>
-                <a:latin typeface="Arial" panose="020B0604020202020204" pitchFamily="34" charset="0"/>
+                <a:latin typeface="Arial" panose="020B[phone redacted]020204" pitchFamily="34" charset="0"/>
                 <a:cs typeface="Assistant"/>
                 <a:sym typeface="Assistant"/>
               </a:rPr>
@@ -19443,7 +19449,7 @@
                 <a:effectLst/>
                 <a:uLnTx/>
                 <a:uFillTx/>
-                <a:latin typeface="Arial" panose="020B0604020202020204" pitchFamily="34" charset="0"/>
+                <a:latin typeface="Arial" panose="020B[phone redacted]020204" pitchFamily="34" charset="0"/>
                 <a:cs typeface="Assistant"/>
                 <a:sym typeface="Assistant"/>
               </a:rPr>
@@ -19460,7 +19466,7 @@
                 <a:effectLst/>
                 <a:uLnTx/>
                 <a:uFillTx/>
-                <a:latin typeface="Arial" panose="020B0604020202020204" pitchFamily="34" charset="0"/>
+                <a:latin typeface="Arial" panose="020B[phone redacted]020204" pitchFamily="34" charset="0"/>
                 <a:cs typeface="Assistant"/>
                 <a:sym typeface="Assistant"/>
               </a:rPr>
@@ -19477,7 +19483,7 @@
                 <a:effectLst/>
                 <a:uLnTx/>
                 <a:uFillTx/>
-                <a:latin typeface="Arial" panose="020B0604020202020204" pitchFamily="34" charset="0"/>
+                <a:latin typeface="Arial" panose="020B[phone redacted]020204" pitchFamily="34" charset="0"/>
                 <a:cs typeface="Assistant"/>
                 <a:sym typeface="Assistant"/>
               </a:rPr>
@@ -19515,7 +19521,7 @@
                 <a:effectLst/>
                 <a:uLnTx/>
                 <a:uFillTx/>
-                <a:latin typeface="Arial" panose="020B0604020202020204" pitchFamily="34" charset="0"/>
+                <a:latin typeface="Arial" panose="020B[phone redacted]020204" pitchFamily="34" charset="0"/>
                 <a:cs typeface="Assistant"/>
                 <a:sym typeface="Assistant"/>
               </a:rPr>
@@ -19526,7 +19532,7 @@
                 <a:solidFill>
                   <a:srgbClr val="FFFFFF"/>
                 </a:solidFill>
-                <a:latin typeface="Arial" panose="020B0604020202020204" pitchFamily="34" charset="0"/>
+                <a:latin typeface="Arial" panose="020B[phone redacted]020204" pitchFamily="34" charset="0"/>
                 <a:cs typeface="Assistant"/>
                 <a:sym typeface="Assistant"/>
               </a:rPr>
@@ -19543,7 +19549,7 @@
                 <a:effectLst/>
                 <a:uLnTx/>
                 <a:uFillTx/>
-                <a:latin typeface="Arial" panose="020B0604020202020204" pitchFamily="34" charset="0"/>
+                <a:latin typeface="Arial" panose="020B[phone redacted]020204" pitchFamily="34" charset="0"/>
                 <a:cs typeface="Assistant"/>
                 <a:sym typeface="Assistant"/>
               </a:rPr>
@@ -19580,7 +19586,7 @@
               <a:effectLst/>
               <a:uLnTx/>
               <a:uFillTx/>
-              <a:latin typeface="Arial" panose="020B0604020202020204" pitchFamily="34" charset="0"/>
+              <a:latin typeface="Arial" panose="020B[phone redacted]020204" pitchFamily="34" charset="0"/>
               <a:cs typeface="Assistant"/>
               <a:sym typeface="Assistant"/>
             </a:endParaRPr>
@@ -19616,7 +19622,7 @@
                 <a:effectLst/>
                 <a:uLnTx/>
                 <a:uFillTx/>
-                <a:latin typeface="Arial" panose="020B0604020202020204" pitchFamily="34" charset="0"/>
+                <a:latin typeface="Arial" panose="020B[phone redacted]020204" pitchFamily="34" charset="0"/>
                 <a:cs typeface="Assistant"/>
                 <a:sym typeface="Assistant"/>
               </a:rPr>
@@ -19633,7 +19639,7 @@
                 <a:effectLst/>
                 <a:uLnTx/>
                 <a:uFillTx/>
-                <a:latin typeface="Arial" panose="020B0604020202020204" pitchFamily="34" charset="0"/>
+                <a:latin typeface="Arial" panose="020B[phone redacted]020204" pitchFamily="34" charset="0"/>
                 <a:cs typeface="Assistant"/>
                 <a:sym typeface="Assistant"/>
               </a:rPr>
@@ -19671,7 +19677,7 @@
                 <a:effectLst/>
                 <a:uLnTx/>
                 <a:uFillTx/>
-                <a:latin typeface="Arial" panose="020B0604020202020204" pitchFamily="34" charset="0"/>
+                <a:latin typeface="Arial" panose="020B[phone redacted]020204" pitchFamily="34" charset="0"/>
                 <a:cs typeface="Assistant"/>
                 <a:sym typeface="Assistant"/>
               </a:rPr>
@@ -19703,7 +19709,7 @@
                 <a:solidFill>
                   <a:srgbClr val="FFFFFF"/>
                 </a:solidFill>
-                <a:latin typeface="Arial" panose="020B0604020202020204" pitchFamily="34" charset="0"/>
+                <a:latin typeface="Arial" panose="020B[phone redacted]020204" pitchFamily="34" charset="0"/>
                 <a:cs typeface="Assistant"/>
                 <a:sym typeface="Assistant"/>
               </a:rPr>
@@ -19720,7 +19726,7 @@
                 <a:effectLst/>
                 <a:uLnTx/>
                 <a:uFillTx/>
-                <a:latin typeface="Arial" panose="020B0604020202020204" pitchFamily="34" charset="0"/>
+                <a:latin typeface="Arial" panose="020B[phone redacted]020204" pitchFamily="34" charset="0"/>
                 <a:cs typeface="Assistant"/>
                 <a:sym typeface="Assistant"/>
               </a:rPr>
@@ -19737,7 +19743,7 @@
                 <a:effectLst/>
                 <a:uLnTx/>
                 <a:uFillTx/>
-                <a:latin typeface="Arial" panose="020B0604020202020204" pitchFamily="34" charset="0"/>
+                <a:latin typeface="Arial" panose="020B[phone redacted]020204" pitchFamily="34" charset="0"/>
                 <a:cs typeface="Assistant"/>
                 <a:sym typeface="Assistant"/>
               </a:rPr>
@@ -19754,7 +19760,7 @@
                 <a:effectLst/>
                 <a:uLnTx/>
                 <a:uFillTx/>
-                <a:latin typeface="Arial" panose="020B0604020202020204" pitchFamily="34" charset="0"/>
+                <a:latin typeface="Arial" panose="020B[phone redacted]020204" pitchFamily="34" charset="0"/>
                 <a:cs typeface="Assistant"/>
                 <a:sym typeface="Assistant"/>
               </a:rPr>
@@ -19792,7 +19798,7 @@
                 <a:effectLst/>
                 <a:uLnTx/>
                 <a:uFillTx/>
-                <a:latin typeface="Arial" panose="020B0604020202020204" pitchFamily="34" charset="0"/>
+                <a:latin typeface="Arial" panose="020B[phone redacted]020204" pitchFamily="34" charset="0"/>
                 <a:cs typeface="Assistant"/>
                 <a:sym typeface="Assistant"/>
               </a:rPr>
@@ -19809,7 +19815,7 @@
                 <a:effectLst/>
                 <a:uLnTx/>
                 <a:uFillTx/>
-                <a:latin typeface="Arial" panose="020B0604020202020204" pitchFamily="34" charset="0"/>
+                <a:latin typeface="Arial" panose="020B[phone redacted]020204" pitchFamily="34" charset="0"/>
                 <a:cs typeface="Assistant"/>
                 <a:sym typeface="Assistant"/>
               </a:rPr>
@@ -19826,7 +19832,7 @@
                 <a:effectLst/>
                 <a:uLnTx/>
                 <a:uFillTx/>
-                <a:latin typeface="Arial" panose="020B0604020202020204" pitchFamily="34" charset="0"/>
+                <a:latin typeface="Arial" panose="020B[phone redacted]020204" pitchFamily="34" charset="0"/>
                 <a:cs typeface="Assistant"/>
                 <a:sym typeface="Assistant"/>
               </a:rPr>
@@ -19864,7 +19870,7 @@
                 <a:effectLst/>
                 <a:uLnTx/>
                 <a:uFillTx/>
-                <a:latin typeface="Arial" panose="020B0604020202020204" pitchFamily="34" charset="0"/>
+                <a:latin typeface="Arial" panose="020B[phone redacted]020204" pitchFamily="34" charset="0"/>
                 <a:cs typeface="Assistant"/>
                 <a:sym typeface="Assistant"/>
               </a:rPr>
@@ -19881,7 +19887,7 @@
                 <a:effectLst/>
                 <a:uLnTx/>
                 <a:uFillTx/>
-                <a:latin typeface="Arial" panose="020B0604020202020204" pitchFamily="34" charset="0"/>
+                <a:latin typeface="Arial" panose="020B[phone redacted]020204" pitchFamily="34" charset="0"/>
                 <a:cs typeface="Assistant"/>
                 <a:sym typeface="Assistant"/>
               </a:rPr>
@@ -19898,7 +19904,7 @@
                 <a:effectLst/>
                 <a:uLnTx/>
                 <a:uFillTx/>
-                <a:latin typeface="Arial" panose="020B0604020202020204" pitchFamily="34" charset="0"/>
+                <a:latin typeface="Arial" panose="020B[phone redacted]020204" pitchFamily="34" charset="0"/>
                 <a:cs typeface="Assistant"/>
                 <a:sym typeface="Assistant"/>
               </a:rPr>
@@ -19936,7 +19942,7 @@
                 <a:effectLst/>
                 <a:uLnTx/>
                 <a:uFillTx/>
-                <a:latin typeface="Arial" panose="020B0604020202020204" pitchFamily="34" charset="0"/>
+                <a:latin typeface="Arial" panose="020B[phone redacted]020204" pitchFamily="34" charset="0"/>
                 <a:cs typeface="Assistant"/>
                 <a:sym typeface="Assistant"/>
               </a:rPr>
@@ -19953,7 +19959,7 @@
                 <a:effectLst/>
                 <a:uLnTx/>
                 <a:uFillTx/>
-                <a:latin typeface="Arial" panose="020B0604020202020204" pitchFamily="34" charset="0"/>
+                <a:latin typeface="Arial" panose="020B[phone redacted]020204" pitchFamily="34" charset="0"/>
                 <a:cs typeface="Assistant"/>
                 <a:sym typeface="Assistant"/>
               </a:rPr>
@@ -19970,7 +19976,7 @@
                 <a:effectLst/>
                 <a:uLnTx/>
                 <a:uFillTx/>
-                <a:latin typeface="Arial" panose="020B0604020202020204" pitchFamily="34" charset="0"/>
+                <a:latin typeface="Arial" panose="020B[phone redacted]020204" pitchFamily="34" charset="0"/>
                 <a:cs typeface="Assistant"/>
                 <a:sym typeface="Assistant"/>
               </a:rPr>
@@ -19987,7 +19993,7 @@
                 <a:effectLst/>
                 <a:uLnTx/>
                 <a:uFillTx/>
-                <a:latin typeface="Arial" panose="020B0604020202020204" pitchFamily="34" charset="0"/>
+                <a:latin typeface="Arial" panose="020B[phone redacted]020204" pitchFamily="34" charset="0"/>
                 <a:cs typeface="Assistant"/>
                 <a:sym typeface="Assistant"/>
               </a:rPr>
@@ -20024,7 +20030,7 @@
               <a:effectLst/>
               <a:uLnTx/>
               <a:uFillTx/>
-              <a:latin typeface="Arial" panose="020B0604020202020204" pitchFamily="34" charset="0"/>
+              <a:latin typeface="Arial" panose="020B[phone redacted]020204" pitchFamily="34" charset="0"/>
               <a:cs typeface="Assistant"/>
               <a:sym typeface="Assistant"/>
             </a:endParaRPr>
@@ -20060,7 +20066,7 @@
                 <a:effectLst/>
                 <a:uLnTx/>
                 <a:uFillTx/>
-                <a:latin typeface="Arial" panose="020B0604020202020204" pitchFamily="34" charset="0"/>
+                <a:latin typeface="Arial" panose="020B[phone redacted]020204" pitchFamily="34" charset="0"/>
                 <a:cs typeface="Assistant"/>
                 <a:sym typeface="Assistant"/>
               </a:rPr>
@@ -20170,7 +20176,7 @@
                 <a:effectLst/>
                 <a:uLnTx/>
                 <a:uFillTx/>
-                <a:latin typeface="Arial" panose="020B0604020202020204" pitchFamily="34" charset="0"/>
+                <a:latin typeface="Arial" panose="020B[phone redacted]020204" pitchFamily="34" charset="0"/>
                 <a:cs typeface="Assistant"/>
                 <a:sym typeface="Assistant"/>
               </a:rPr>
@@ -20187,7 +20193,7 @@
                 <a:effectLst/>
                 <a:uLnTx/>
                 <a:uFillTx/>
-                <a:latin typeface="Arial" panose="020B0604020202020204" pitchFamily="34" charset="0"/>
+                <a:latin typeface="Arial" panose="020B[phone redacted]020204" pitchFamily="34" charset="0"/>
                 <a:cs typeface="Assistant"/>
                 <a:sym typeface="Assistant"/>
               </a:rPr>
@@ -20204,7 +20210,7 @@
                 <a:effectLst/>
                 <a:uLnTx/>
                 <a:uFillTx/>
-                <a:latin typeface="Arial" panose="020B0604020202020204" pitchFamily="34" charset="0"/>
+                <a:latin typeface="Arial" panose="020B[phone redacted]020204" pitchFamily="34" charset="0"/>
                 <a:cs typeface="Assistant"/>
                 <a:sym typeface="Assistant"/>
               </a:rPr>
@@ -20221,7 +20227,7 @@
                 <a:effectLst/>
                 <a:uLnTx/>
                 <a:uFillTx/>
-                <a:latin typeface="Arial" panose="020B0604020202020204" pitchFamily="34" charset="0"/>
+                <a:latin typeface="Arial" panose="020B[phone redacted]020204" pitchFamily="34" charset="0"/>
                 <a:cs typeface="Assistant"/>
                 <a:sym typeface="Assistant"/>
               </a:rPr>
@@ -20259,7 +20265,7 @@
                 <a:effectLst/>
                 <a:uLnTx/>
                 <a:uFillTx/>
-                <a:latin typeface="Arial" panose="020B0604020202020204" pitchFamily="34" charset="0"/>
+                <a:latin typeface="Arial" panose="020B[phone redacted]020204" pitchFamily="34" charset="0"/>
                 <a:cs typeface="Assistant"/>
                 <a:sym typeface="Assistant"/>
               </a:rPr>
@@ -20297,7 +20303,7 @@
                 <a:effectLst/>
                 <a:uLnTx/>
                 <a:uFillTx/>
-                <a:latin typeface="Arial" panose="020B0604020202020204" pitchFamily="34" charset="0"/>
+                <a:latin typeface="Arial" panose="020B[phone redacted]020204" pitchFamily="34" charset="0"/>
                 <a:cs typeface="Assistant"/>
                 <a:sym typeface="Assistant"/>
               </a:rPr>
@@ -20314,7 +20320,7 @@
                 <a:effectLst/>
                 <a:uLnTx/>
                 <a:uFillTx/>
-                <a:latin typeface="Arial" panose="020B0604020202020204" pitchFamily="34" charset="0"/>
+                <a:latin typeface="Arial" panose="020B[phone redacted]020204" pitchFamily="34" charset="0"/>
                 <a:cs typeface="Assistant"/>
                 <a:sym typeface="Assistant"/>
               </a:rPr>
@@ -20331,7 +20337,7 @@
                 <a:effectLst/>
                 <a:uLnTx/>
                 <a:uFillTx/>
-                <a:latin typeface="Arial" panose="020B0604020202020204" pitchFamily="34" charset="0"/>
+                <a:latin typeface="Arial" panose="020B[phone redacted]020204" pitchFamily="34" charset="0"/>
                 <a:cs typeface="Assistant"/>
                 <a:sym typeface="Assistant"/>
               </a:rPr>
@@ -20348,7 +20354,7 @@
                 <a:effectLst/>
                 <a:uLnTx/>
                 <a:uFillTx/>
-                <a:latin typeface="Arial" panose="020B0604020202020204" pitchFamily="34" charset="0"/>
+                <a:latin typeface="Arial" panose="020B[phone redacted]020204" pitchFamily="34" charset="0"/>
                 <a:cs typeface="Assistant"/>
                 <a:sym typeface="Assistant"/>
               </a:rPr>
@@ -20365,7 +20371,7 @@
                 <a:effectLst/>
                 <a:uLnTx/>
                 <a:uFillTx/>
-                <a:latin typeface="Arial" panose="020B0604020202020204" pitchFamily="34" charset="0"/>
+                <a:latin typeface="Arial" panose="020B[phone redacted]020204" pitchFamily="34" charset="0"/>
                 <a:cs typeface="Assistant"/>
                 <a:sym typeface="Assistant"/>
               </a:rPr>
@@ -20403,7 +20409,7 @@
                 <a:effectLst/>
                 <a:uLnTx/>
                 <a:uFillTx/>
-                <a:latin typeface="Arial" panose="020B0604020202020204" pitchFamily="34" charset="0"/>
+                <a:latin typeface="Arial" panose="020B[phone redacted]020204" pitchFamily="34" charset="0"/>
                 <a:cs typeface="Assistant"/>
                 <a:sym typeface="Assistant"/>
               </a:rPr>
@@ -20420,7 +20426,7 @@
                 <a:effectLst/>
                 <a:uLnTx/>
                 <a:uFillTx/>
-                <a:latin typeface="Arial" panose="020B0604020202020204" pitchFamily="34" charset="0"/>
+                <a:latin typeface="Arial" panose="020B[phone redacted]020204" pitchFamily="34" charset="0"/>
                 <a:cs typeface="Assistant"/>
                 <a:sym typeface="Assistant"/>
               </a:rPr>
@@ -20437,7 +20443,7 @@
                 <a:effectLst/>
                 <a:uLnTx/>
                 <a:uFillTx/>
-                <a:latin typeface="Arial" panose="020B0604020202020204" pitchFamily="34" charset="0"/>
+                <a:latin typeface="Arial" panose="020B[phone redacted]020204" pitchFamily="34" charset="0"/>
                 <a:cs typeface="Assistant"/>
                 <a:sym typeface="Assistant"/>
               </a:rPr>
@@ -20454,7 +20460,7 @@
                 <a:effectLst/>
                 <a:uLnTx/>
                 <a:uFillTx/>
-                <a:latin typeface="Arial" panose="020B0604020202020204" pitchFamily="34" charset="0"/>
+                <a:latin typeface="Arial" panose="020B[phone redacted]020204" pitchFamily="34" charset="0"/>
                 <a:cs typeface="Assistant"/>
                 <a:sym typeface="Assistant"/>
               </a:rPr>
@@ -20471,7 +20477,7 @@
                 <a:effectLst/>
                 <a:uLnTx/>
                 <a:uFillTx/>
-                <a:latin typeface="Arial" panose="020B0604020202020204" pitchFamily="34" charset="0"/>
+                <a:latin typeface="Arial" panose="020B[phone redacted]020204" pitchFamily="34" charset="0"/>
                 <a:cs typeface="Assistant"/>
                 <a:sym typeface="Assistant"/>
               </a:rPr>
@@ -20509,7 +20515,7 @@
                 <a:effectLst/>
                 <a:uLnTx/>
                 <a:uFillTx/>
-                <a:latin typeface="Arial" panose="020B0604020202020204" pitchFamily="34" charset="0"/>
+                <a:latin typeface="Arial" panose="020B[phone redacted]020204" pitchFamily="34" charset="0"/>
                 <a:cs typeface="Assistant"/>
                 <a:sym typeface="Assistant"/>
               </a:rPr>
@@ -20526,7 +20532,7 @@
                 <a:effectLst/>
                 <a:uLnTx/>
                 <a:uFillTx/>
-                <a:latin typeface="Arial" panose="020B0604020202020204" pitchFamily="34" charset="0"/>
+                <a:latin typeface="Arial" panose="020B[phone redacted]020204" pitchFamily="34" charset="0"/>
                 <a:cs typeface="Assistant"/>
                 <a:sym typeface="Assistant"/>
               </a:rPr>
@@ -20543,7 +20549,7 @@
                 <a:effectLst/>
                 <a:uLnTx/>
                 <a:uFillTx/>
-                <a:latin typeface="Arial" panose="020B0604020202020204" pitchFamily="34" charset="0"/>
+                <a:latin typeface="Arial" panose="020B[phone redacted]020204" pitchFamily="34" charset="0"/>
                 <a:cs typeface="Assistant"/>
                 <a:sym typeface="Assistant"/>
               </a:rPr>
@@ -20560,7 +20566,7 @@
                 <a:effectLst/>
                 <a:uLnTx/>
                 <a:uFillTx/>
-                <a:latin typeface="Arial" panose="020B0604020202020204" pitchFamily="34" charset="0"/>
+                <a:latin typeface="Arial" panose="020B[phone redacted]020204" pitchFamily="34" charset="0"/>
                 <a:cs typeface="Assistant"/>
                 <a:sym typeface="Assistant"/>
               </a:rPr>
@@ -20577,7 +20583,7 @@
                 <a:effectLst/>
                 <a:uLnTx/>
                 <a:uFillTx/>
-                <a:latin typeface="Arial" panose="020B0604020202020204" pitchFamily="34" charset="0"/>
+                <a:latin typeface="Arial" panose="020B[phone redacted]020204" pitchFamily="34" charset="0"/>
                 <a:cs typeface="Assistant"/>
                 <a:sym typeface="Assistant"/>
               </a:rPr>
@@ -20615,7 +20621,7 @@
                 <a:effectLst/>
                 <a:uLnTx/>
                 <a:uFillTx/>
-                <a:latin typeface="Arial" panose="020B0604020202020204" pitchFamily="34" charset="0"/>
+                <a:latin typeface="Arial" panose="020B[phone redacted]020204" pitchFamily="34" charset="0"/>
                 <a:cs typeface="Assistant"/>
                 <a:sym typeface="Assistant"/>
               </a:rPr>
@@ -20632,7 +20638,7 @@
                 <a:effectLst/>
                 <a:uLnTx/>
                 <a:uFillTx/>
-                <a:latin typeface="Arial" panose="020B0604020202020204" pitchFamily="34" charset="0"/>
+                <a:latin typeface="Arial" panose="020B[phone redacted]020204" pitchFamily="34" charset="0"/>
                 <a:cs typeface="Assistant"/>
                 <a:sym typeface="Assistant"/>
               </a:rPr>
@@ -20649,7 +20655,7 @@
                 <a:effectLst/>
                 <a:uLnTx/>
                 <a:uFillTx/>
-                <a:latin typeface="Arial" panose="020B0604020202020204" pitchFamily="34" charset="0"/>
+                <a:latin typeface="Arial" panose="020B[phone redacted]020204" pitchFamily="34" charset="0"/>
                 <a:cs typeface="Assistant"/>
                 <a:sym typeface="Assistant"/>
               </a:rPr>
@@ -20666,7 +20672,7 @@
                 <a:effectLst/>
                 <a:uLnTx/>
                 <a:uFillTx/>
-                <a:latin typeface="Arial" panose="020B0604020202020204" pitchFamily="34" charset="0"/>
+                <a:latin typeface="Arial" panose="020B[phone redacted]020204" pitchFamily="34" charset="0"/>
                 <a:cs typeface="Assistant"/>
                 <a:sym typeface="Assistant"/>
               </a:rPr>
@@ -20683,7 +20689,7 @@
                 <a:effectLst/>
                 <a:uLnTx/>
                 <a:uFillTx/>
-                <a:latin typeface="Arial" panose="020B0604020202020204" pitchFamily="34" charset="0"/>
+                <a:latin typeface="Arial" panose="020B[phone redacted]020204" pitchFamily="34" charset="0"/>
                 <a:cs typeface="Assistant"/>
                 <a:sym typeface="Assistant"/>
               </a:rPr>
@@ -20721,7 +20727,7 @@
                 <a:effectLst/>
                 <a:uLnTx/>
                 <a:uFillTx/>
-                <a:latin typeface="Arial" panose="020B0604020202020204" pitchFamily="34" charset="0"/>
+                <a:latin typeface="Arial" panose="020B[phone redacted]020204" pitchFamily="34" charset="0"/>
                 <a:cs typeface="Assistant"/>
                 <a:sym typeface="Assistant"/>
               </a:rPr>
@@ -20738,7 +20744,7 @@
                 <a:effectLst/>
                 <a:uLnTx/>
                 <a:uFillTx/>
-                <a:latin typeface="Arial" panose="020B0604020202020204" pitchFamily="34" charset="0"/>
+                <a:latin typeface="Arial" panose="020B[phone redacted]020204" pitchFamily="34" charset="0"/>
                 <a:cs typeface="Assistant"/>
                 <a:sym typeface="Assistant"/>
               </a:rPr>
@@ -20755,7 +20761,7 @@
                 <a:effectLst/>
                 <a:uLnTx/>
                 <a:uFillTx/>
-                <a:latin typeface="Arial" panose="020B0604020202020204" pitchFamily="34" charset="0"/>
+                <a:latin typeface="Arial" panose="020B[phone redacted]020204" pitchFamily="34" charset="0"/>
                 <a:cs typeface="Assistant"/>
                 <a:sym typeface="Assistant"/>
               </a:rPr>
@@ -20772,7 +20778,7 @@
                 <a:effectLst/>
                 <a:uLnTx/>
                 <a:uFillTx/>
-                <a:latin typeface="Arial" panose="020B0604020202020204" pitchFamily="34" charset="0"/>
+                <a:latin typeface="Arial" panose="020B[phone redacted]020204" pitchFamily="34" charset="0"/>
                 <a:cs typeface="Assistant"/>
                 <a:sym typeface="Assistant"/>
               </a:rPr>
@@ -20789,7 +20795,7 @@
                 <a:effectLst/>
                 <a:uLnTx/>
                 <a:uFillTx/>
-                <a:latin typeface="Arial" panose="020B0604020202020204" pitchFamily="34" charset="0"/>
+                <a:latin typeface="Arial" panose="020B[phone redacted]020204" pitchFamily="34" charset="0"/>
                 <a:cs typeface="Assistant"/>
                 <a:sym typeface="Assistant"/>
               </a:rPr>
@@ -20827,7 +20833,7 @@
                 <a:effectLst/>
                 <a:uLnTx/>
                 <a:uFillTx/>
-                <a:latin typeface="Arial" panose="020B0604020202020204" pitchFamily="34" charset="0"/>
+                <a:latin typeface="Arial" panose="020B[phone redacted]020204" pitchFamily="34" charset="0"/>
                 <a:cs typeface="Assistant"/>
                 <a:sym typeface="Assistant"/>
               </a:rPr>
@@ -20844,7 +20850,7 @@
                 <a:effectLst/>
                 <a:uLnTx/>
                 <a:uFillTx/>
-                <a:latin typeface="Arial" panose="020B0604020202020204" pitchFamily="34" charset="0"/>
+                <a:latin typeface="Arial" panose="020B[phone redacted]020204" pitchFamily="34" charset="0"/>
                 <a:cs typeface="Assistant"/>
                 <a:sym typeface="Assistant"/>
               </a:rPr>
@@ -20861,7 +20867,7 @@
                 <a:effectLst/>
                 <a:uLnTx/>
                 <a:uFillTx/>
-                <a:latin typeface="Arial" panose="020B0604020202020204" pitchFamily="34" charset="0"/>
+                <a:latin typeface="Arial" panose="020B[phone redacted]020204" pitchFamily="34" charset="0"/>
                 <a:cs typeface="Assistant"/>
                 <a:sym typeface="Assistant"/>
               </a:rPr>
@@ -20899,7 +20905,7 @@
                 <a:effectLst/>
                 <a:uLnTx/>
                 <a:uFillTx/>
-                <a:latin typeface="Arial" panose="020B0604020202020204" pitchFamily="34" charset="0"/>
+                <a:latin typeface="Arial" panose="020B[phone redacted]020204" pitchFamily="34" charset="0"/>
                 <a:cs typeface="Assistant"/>
                 <a:sym typeface="Assistant"/>
               </a:rPr>
@@ -20937,7 +20943,7 @@
                 <a:effectLst/>
                 <a:uLnTx/>
                 <a:uFillTx/>
-                <a:latin typeface="Arial" panose="020B0604020202020204" pitchFamily="34" charset="0"/>
+                <a:latin typeface="Arial" panose="020B[phone redacted]020204" pitchFamily="34" charset="0"/>
                 <a:cs typeface="Assistant"/>
                 <a:sym typeface="Assistant"/>
               </a:rPr>
@@ -20954,7 +20960,7 @@
                 <a:effectLst/>
                 <a:uLnTx/>
                 <a:uFillTx/>
-                <a:latin typeface="Arial" panose="020B0604020202020204" pitchFamily="34" charset="0"/>
+                <a:latin typeface="Arial" panose="020B[phone redacted]020204" pitchFamily="34" charset="0"/>
                 <a:cs typeface="Assistant"/>
                 <a:sym typeface="Assistant"/>
               </a:rPr>
@@ -20971,7 +20977,7 @@
                 <a:effectLst/>
                 <a:uLnTx/>
                 <a:uFillTx/>
-                <a:latin typeface="Arial" panose="020B0604020202020204" pitchFamily="34" charset="0"/>
+                <a:latin typeface="Arial" panose="020B[phone redacted]020204" pitchFamily="34" charset="0"/>
                 <a:cs typeface="Assistant"/>
                 <a:sym typeface="Assistant"/>
               </a:rPr>
@@ -20988,7 +20994,7 @@
                 <a:effectLst/>
                 <a:uLnTx/>
                 <a:uFillTx/>
-                <a:latin typeface="Arial" panose="020B0604020202020204" pitchFamily="34" charset="0"/>
+                <a:latin typeface="Arial" panose="020B[phone redacted]020204" pitchFamily="34" charset="0"/>
                 <a:cs typeface="Assistant"/>
                 <a:sym typeface="Assistant"/>
               </a:rPr>
@@ -21005,7 +21011,7 @@
                 <a:effectLst/>
                 <a:uLnTx/>
                 <a:uFillTx/>
-                <a:latin typeface="Arial" panose="020B0604020202020204" pitchFamily="34" charset="0"/>
+                <a:latin typeface="Arial" panose="020B[phone redacted]020204" pitchFamily="34" charset="0"/>
                 <a:cs typeface="Assistant"/>
                 <a:sym typeface="Assistant"/>
               </a:rPr>
@@ -21043,7 +21049,7 @@
                 <a:effectLst/>
                 <a:uLnTx/>
                 <a:uFillTx/>
-                <a:latin typeface="Arial" panose="020B0604020202020204" pitchFamily="34" charset="0"/>
+                <a:latin typeface="Arial" panose="020B[phone redacted]020204" pitchFamily="34" charset="0"/>
                 <a:cs typeface="Assistant"/>
                 <a:sym typeface="Assistant"/>
               </a:rPr>
@@ -21060,7 +21066,7 @@
                 <a:effectLst/>
                 <a:uLnTx/>
                 <a:uFillTx/>
-                <a:latin typeface="Arial" panose="020B0604020202020204" pitchFamily="34" charset="0"/>
+                <a:latin typeface="Arial" panose="020B[phone redacted]020204" pitchFamily="34" charset="0"/>
                 <a:cs typeface="Assistant"/>
                 <a:sym typeface="Assistant"/>
               </a:rPr>
@@ -21077,7 +21083,7 @@
                 <a:effectLst/>
                 <a:uLnTx/>
                 <a:uFillTx/>
-                <a:latin typeface="Arial" panose="020B0604020202020204" pitchFamily="34" charset="0"/>
+                <a:latin typeface="Arial" panose="020B[phone redacted]020204" pitchFamily="34" charset="0"/>
                 <a:cs typeface="Assistant"/>
                 <a:sym typeface="Assistant"/>
               </a:rPr>
@@ -21115,7 +21121,7 @@
                 <a:effectLst/>
                 <a:uLnTx/>
                 <a:uFillTx/>
-                <a:latin typeface="Arial" panose="020B0604020202020204" pitchFamily="34" charset="0"/>
+                <a:latin typeface="Arial" panose="020B[phone redacted]020204" pitchFamily="34" charset="0"/>
                 <a:cs typeface="Assistant"/>
                 <a:sym typeface="Assistant"/>
               </a:rPr>
@@ -21132,7 +21138,7 @@
                 <a:effectLst/>
                 <a:uLnTx/>
                 <a:uFillTx/>
-                <a:latin typeface="Arial" panose="020B0604020202020204" pitchFamily="34" charset="0"/>
+                <a:latin typeface="Arial" panose="020B[phone redacted]020204" pitchFamily="34" charset="0"/>
                 <a:cs typeface="Assistant"/>
                 <a:sym typeface="Assistant"/>
               </a:rPr>
@@ -21149,7 +21155,7 @@
                 <a:effectLst/>
                 <a:uLnTx/>
                 <a:uFillTx/>
-                <a:latin typeface="Arial" panose="020B0604020202020204" pitchFamily="34" charset="0"/>
+                <a:latin typeface="Arial" panose="020B[phone redacted]020204" pitchFamily="34" charset="0"/>
                 <a:cs typeface="Assistant"/>
                 <a:sym typeface="Assistant"/>
               </a:rPr>
@@ -21187,7 +21193,7 @@
                 <a:effectLst/>
                 <a:uLnTx/>
                 <a:uFillTx/>
-                <a:latin typeface="Arial" panose="020B0604020202020204" pitchFamily="34" charset="0"/>
+                <a:latin typeface="Arial" panose="020B[phone redacted]020204" pitchFamily="34" charset="0"/>
                 <a:cs typeface="Assistant"/>
                 <a:sym typeface="Assistant"/>
               </a:rPr>
@@ -21204,7 +21210,7 @@
                 <a:effectLst/>
                 <a:uLnTx/>
                 <a:uFillTx/>
-                <a:latin typeface="Arial" panose="020B0604020202020204" pitchFamily="34" charset="0"/>
+                <a:latin typeface="Arial" panose="020B[phone redacted]020204" pitchFamily="34" charset="0"/>
                 <a:cs typeface="Assistant"/>
                 <a:sym typeface="Assistant"/>
               </a:rPr>
@@ -21221,7 +21227,7 @@
                 <a:effectLst/>
                 <a:uLnTx/>
                 <a:uFillTx/>
-                <a:latin typeface="Arial" panose="020B0604020202020204" pitchFamily="34" charset="0"/>
+                <a:latin typeface="Arial" panose="020B[phone redacted]020204" pitchFamily="34" charset="0"/>
                 <a:cs typeface="Assistant"/>
                 <a:sym typeface="Assistant"/>
               </a:rPr>
@@ -21258,7 +21264,7 @@
               <a:effectLst/>
               <a:uLnTx/>
               <a:uFillTx/>
-              <a:latin typeface="Arial" panose="020B0604020202020204" pitchFamily="34" charset="0"/>
+              <a:latin typeface="Arial" panose="020B[phone redacted]020204" pitchFamily="34" charset="0"/>
               <a:cs typeface="Assistant"/>
               <a:sym typeface="Assistant"/>
             </a:endParaRPr>
@@ -21294,7 +21300,7 @@
                 <a:effectLst/>
                 <a:uLnTx/>
                 <a:uFillTx/>
-                <a:latin typeface="Arial" panose="020B0604020202020204" pitchFamily="34" charset="0"/>
+                <a:latin typeface="Arial" panose="020B[phone redacted]020204" pitchFamily="34" charset="0"/>
                 <a:cs typeface="Assistant"/>
                 <a:sym typeface="Assistant"/>
               </a:rPr>
@@ -21311,7 +21317,7 @@
                 <a:effectLst/>
                 <a:uLnTx/>
                 <a:uFillTx/>
-                <a:latin typeface="Arial" panose="020B0604020202020204" pitchFamily="34" charset="0"/>
+                <a:latin typeface="Arial" panose="020B[phone redacted]020204" pitchFamily="34" charset="0"/>
                 <a:cs typeface="Assistant"/>
                 <a:sym typeface="Assistant"/>
               </a:rPr>
@@ -21349,7 +21355,7 @@
                 <a:effectLst/>
                 <a:uLnTx/>
                 <a:uFillTx/>
-                <a:latin typeface="Arial" panose="020B0604020202020204" pitchFamily="34" charset="0"/>
+                <a:latin typeface="Arial" panose="020B[phone redacted]020204" pitchFamily="34" charset="0"/>
                 <a:cs typeface="Assistant"/>
                 <a:sym typeface="Assistant"/>
               </a:rPr>
@@ -21366,7 +21372,7 @@
                 <a:effectLst/>
                 <a:uLnTx/>
                 <a:uFillTx/>
-                <a:latin typeface="Arial" panose="020B0604020202020204" pitchFamily="34" charset="0"/>
+                <a:latin typeface="Arial" panose="020B[phone redacted]020204" pitchFamily="34" charset="0"/>
                 <a:cs typeface="Assistant"/>
                 <a:sym typeface="Assistant"/>
               </a:rPr>
@@ -21383,7 +21389,7 @@
                 <a:effectLst/>
                 <a:uLnTx/>
                 <a:uFillTx/>
-                <a:latin typeface="Arial" panose="020B0604020202020204" pitchFamily="34" charset="0"/>
+                <a:latin typeface="Arial" panose="020B[phone redacted]020204" pitchFamily="34" charset="0"/>
                 <a:cs typeface="Assistant"/>
                 <a:sym typeface="Assistant"/>
               </a:rPr>
@@ -21421,7 +21427,7 @@
                 <a:effectLst/>
                 <a:uLnTx/>
                 <a:uFillTx/>
-                <a:latin typeface="Arial" panose="020B0604020202020204" pitchFamily="34" charset="0"/>
+                <a:latin typeface="Arial" panose="020B[phone redacted]020204" pitchFamily="34" charset="0"/>
                 <a:cs typeface="Assistant"/>
                 <a:sym typeface="Assistant"/>
               </a:rPr>
@@ -21438,7 +21444,7 @@
                 <a:effectLst/>
                 <a:uLnTx/>
                 <a:uFillTx/>
-                <a:latin typeface="Arial" panose="020B0604020202020204" pitchFamily="34" charset="0"/>
+                <a:latin typeface="Arial" panose="020B[phone redacted]020204" pitchFamily="34" charset="0"/>
                 <a:cs typeface="Assistant"/>
                 <a:sym typeface="Assistant"/>
               </a:rPr>
@@ -21455,7 +21461,7 @@
                 <a:effectLst/>
                 <a:uLnTx/>
                 <a:uFillTx/>
-                <a:latin typeface="Arial" panose="020B0604020202020204" pitchFamily="34" charset="0"/>
+                <a:latin typeface="Arial" panose="020B[phone redacted]020204" pitchFamily="34" charset="0"/>
                 <a:cs typeface="Assistant"/>
                 <a:sym typeface="Assistant"/>
               </a:rPr>
@@ -21493,7 +21499,7 @@
                 <a:effectLst/>
                 <a:uLnTx/>
                 <a:uFillTx/>
-                <a:latin typeface="Arial" panose="020B0604020202020204" pitchFamily="34" charset="0"/>
+                <a:latin typeface="Arial" panose="020B[phone redacted]020204" pitchFamily="34" charset="0"/>
                 <a:cs typeface="Assistant"/>
                 <a:sym typeface="Assistant"/>
               </a:rPr>
@@ -21510,7 +21516,7 @@
                 <a:effectLst/>
                 <a:uLnTx/>
                 <a:uFillTx/>
-                <a:latin typeface="Arial" panose="020B0604020202020204" pitchFamily="34" charset="0"/>
+                <a:latin typeface="Arial" panose="020B[phone redacted]020204" pitchFamily="34" charset="0"/>
                 <a:cs typeface="Assistant"/>
                 <a:sym typeface="Assistant"/>
               </a:rPr>
@@ -21527,7 +21533,7 @@
                 <a:effectLst/>
                 <a:uLnTx/>
                 <a:uFillTx/>
-                <a:latin typeface="Arial" panose="020B0604020202020204" pitchFamily="34" charset="0"/>
+                <a:latin typeface="Arial" panose="020B[phone redacted]020204" pitchFamily="34" charset="0"/>
                 <a:cs typeface="Assistant"/>
                 <a:sym typeface="Assistant"/>
               </a:rPr>
@@ -21565,7 +21571,7 @@
                 <a:effectLst/>
                 <a:uLnTx/>
                 <a:uFillTx/>
-                <a:latin typeface="Arial" panose="020B0604020202020204" pitchFamily="34" charset="0"/>
+                <a:latin typeface="Arial" panose="020B[phone redacted]020204" pitchFamily="34" charset="0"/>
                 <a:cs typeface="Assistant"/>
                 <a:sym typeface="Assistant"/>
               </a:rPr>
@@ -21582,7 +21588,7 @@
                 <a:effectLst/>
                 <a:uLnTx/>
                 <a:uFillTx/>
-                <a:latin typeface="Arial" panose="020B0604020202020204" pitchFamily="34" charset="0"/>
+                <a:latin typeface="Arial" panose="020B[phone redacted]020204" pitchFamily="34" charset="0"/>
                 <a:cs typeface="Assistant"/>
                 <a:sym typeface="Assistant"/>
               </a:rPr>
@@ -21599,7 +21605,7 @@
                 <a:effectLst/>
                 <a:uLnTx/>
                 <a:uFillTx/>
-                <a:latin typeface="Arial" panose="020B0604020202020204" pitchFamily="34" charset="0"/>
+                <a:latin typeface="Arial" panose="020B[phone redacted]020204" pitchFamily="34" charset="0"/>
                 <a:cs typeface="Assistant"/>
                 <a:sym typeface="Assistant"/>
               </a:rPr>
@@ -21631,7 +21637,7 @@
                 <a:solidFill>
                   <a:srgbClr val="FFFFFF"/>
                 </a:solidFill>
-                <a:latin typeface="Arial" panose="020B0604020202020204" pitchFamily="34" charset="0"/>
+                <a:latin typeface="Arial" panose="020B[phone redacted]020204" pitchFamily="34" charset="0"/>
                 <a:cs typeface="Assistant"/>
                 <a:sym typeface="Assistant"/>
               </a:rPr>
@@ -21648,7 +21654,7 @@
                 <a:effectLst/>
                 <a:uLnTx/>
                 <a:uFillTx/>
-                <a:latin typeface="Arial" panose="020B0604020202020204" pitchFamily="34" charset="0"/>
+                <a:latin typeface="Arial" panose="020B[phone redacted]020204" pitchFamily="34" charset="0"/>
                 <a:cs typeface="Assistant"/>
                 <a:sym typeface="Assistant"/>
               </a:rPr>
@@ -21665,7 +21671,7 @@
                 <a:effectLst/>
                 <a:uLnTx/>
                 <a:uFillTx/>
-                <a:latin typeface="Arial" panose="020B0604020202020204" pitchFamily="34" charset="0"/>
+                <a:latin typeface="Arial" panose="020B[phone redacted]020204" pitchFamily="34" charset="0"/>
                 <a:cs typeface="Assistant"/>
                 <a:sym typeface="Assistant"/>
               </a:rPr>
@@ -21703,7 +21709,7 @@
                 <a:effectLst/>
                 <a:uLnTx/>
                 <a:uFillTx/>
-                <a:latin typeface="Arial" panose="020B0604020202020204" pitchFamily="34" charset="0"/>
+                <a:latin typeface="Arial" panose="020B[phone redacted]020204" pitchFamily="34" charset="0"/>
                 <a:cs typeface="Assistant"/>
                 <a:sym typeface="Assistant"/>
               </a:rPr>
@@ -22224,7 +22230,7 @@
         <p:spPr>
           <a:xfrm>
             <a:off x="3434079" y="535081"/>
-            <a:ext cx="5787813" cy="307777"/>
+            <a:ext cx="5787813" cy="523220"/>
           </a:xfrm>
           <a:prstGeom prst="rect">
             <a:avLst/>
@@ -22238,10 +22244,17 @@
           <a:lstStyle/>
           <a:p>
             <a:r>
-              <a:rPr lang="fr-FR">
+              <a:rPr lang="fr-FR" dirty="0">
                 <a:solidFill>
                   <a:schemeClr val="accent6"/>
                 </a:solidFill>
+                <a:hlinkClick r:id="rId4">
+                  <a:extLst>
+                    <a:ext uri="{A12FA001-AC4F-418D-AE19-62706E023703}">
+                      <ahyp:hlinkClr xmlns:ahyp="http://schemas.microsoft.com/office/drawing/2018/hyperlinkcolor" val="tx"/>
+                    </a:ext>
+                  </a:extLst>
+                </a:hlinkClick>
               </a:rPr>
               <a:t>https://www.tinkercad.com/</a:t>
             </a:r>
@@ -22464,24 +22477,21 @@
                 <a:effectLst/>
                 <a:latin typeface="artifakt-element"/>
               </a:rPr>
-              <a:t>Allumer une LED avec un bouton poussoir</a:t>
+              <a:t>Allumer une LED avec un bouton poussoir: </a:t>
             </a:r>
             <a:r>
-              <a:rPr lang="fr-FR" b="1">
-                <a:solidFill>
-                  <a:schemeClr val="bg1"/>
-                </a:solidFill>
-                <a:effectLst/>
-                <a:latin typeface="artifakt-element"/>
-              </a:rPr>
-              <a:t>: </a:t>
-            </a:r>
-            <a:r>
-              <a:rPr lang="fr-FR" b="1">
+              <a:rPr lang="fr-FR" b="1" dirty="0">
                 <a:solidFill>
                   <a:schemeClr val="accent6"/>
                 </a:solidFill>
                 <a:latin typeface="+mn-lt"/>
+                <a:hlinkClick r:id="rId2">
+                  <a:extLst>
+                    <a:ext uri="{A12FA001-AC4F-418D-AE19-62706E023703}">
+                      <ahyp:hlinkClr xmlns:ahyp="http://schemas.microsoft.com/office/drawing/2018/hyperlinkcolor" val="tx"/>
+                    </a:ext>
+                  </a:extLst>
+                </a:hlinkClick>
               </a:rPr>
               <a:t>https://www.tinkercad.com/</a:t>
             </a:r>
@@ -22522,11 +22532,18 @@
               <a:buNone/>
             </a:pPr>
             <a:r>
-              <a:rPr lang="fr-FR" b="1">
+              <a:rPr lang="fr-FR" b="1" dirty="0">
                 <a:solidFill>
                   <a:schemeClr val="accent6"/>
                 </a:solidFill>
                 <a:latin typeface="+mn-lt"/>
+                <a:hlinkClick r:id="rId3">
+                  <a:extLst>
+                    <a:ext uri="{A12FA001-AC4F-418D-AE19-62706E023703}">
+                      <ahyp:hlinkClr xmlns:ahyp="http://schemas.microsoft.com/office/drawing/2018/hyperlinkcolor" val="tx"/>
+                    </a:ext>
+                  </a:extLst>
+                </a:hlinkClick>
               </a:rPr>
               <a:t>https://www.tinkercad.com/</a:t>
             </a:r>

</xml_diff>